<commit_message>
feat(p01): add 17 standalone runnable code examples and inject GitHub links into PPTX slides
</commit_message>
<xml_diff>
--- a/03_slide_presentasi/PERTEMUAN_01_Pengantar_Flutter_dan_Ekosistem.pptx
+++ b/03_slide_presentasi/PERTEMUAN_01_Pengantar_Flutter_dan_Ekosistem.pptx
@@ -3897,7 +3897,7 @@
               </a:defRPr>
             </a:pPr>
             <a:r>
-              <a:t>pubspec.yaml  |  KODE / TERMINAL BERSIH</a:t>
+              <a:t>pubspec.yaml  |  KODE IMPLEMENTASI</a:t>
             </a:r>
           </a:p>
         </p:txBody>
@@ -3910,8 +3910,8 @@
         </p:nvSpPr>
         <p:spPr>
           <a:xfrm>
-            <a:off x="5669280" y="2176272"/>
-            <a:ext cx="5486400" cy="3977639"/>
+            <a:off x="5669280" y="2121408"/>
+            <a:ext cx="5486400" cy="3364992"/>
           </a:xfrm>
           <a:prstGeom prst="rect">
             <a:avLst/>
@@ -3925,7 +3925,7 @@
           <a:lstStyle/>
           <a:p>
             <a:pPr>
-              <a:defRPr sz="980">
+              <a:defRPr sz="919">
                 <a:solidFill>
                   <a:srgbClr val="F5F5F5"/>
                 </a:solidFill>
@@ -3993,6 +3993,142 @@
             <a:br/>
             <a:r>
               <a:t>  #   - assets/images/logo.png</a:t>
+            </a:r>
+          </a:p>
+        </p:txBody>
+      </p:sp>
+      <p:sp>
+        <p:nvSpPr>
+          <p:cNvPr id="15" name="Rectangle 14"/>
+          <p:cNvSpPr/>
+          <p:nvPr/>
+        </p:nvSpPr>
+        <p:spPr>
+          <a:xfrm>
+            <a:off x="5660136" y="5669280"/>
+            <a:ext cx="5608015" cy="548640"/>
+          </a:xfrm>
+          <a:prstGeom prst="rect">
+            <a:avLst/>
+          </a:prstGeom>
+          <a:solidFill>
+            <a:srgbClr val="000000"/>
+          </a:solidFill>
+          <a:ln>
+            <a:noFill/>
+          </a:ln>
+        </p:spPr>
+        <p:style>
+          <a:lnRef idx="1">
+            <a:schemeClr val="accent1"/>
+          </a:lnRef>
+          <a:fillRef idx="3">
+            <a:schemeClr val="accent1"/>
+          </a:fillRef>
+          <a:effectRef idx="2">
+            <a:schemeClr val="accent1"/>
+          </a:effectRef>
+          <a:fontRef idx="minor">
+            <a:schemeClr val="lt1"/>
+          </a:fontRef>
+        </p:style>
+        <p:txBody>
+          <a:bodyPr rtlCol="0" anchor="ctr"/>
+          <a:lstStyle/>
+          <a:p>
+            <a:pPr algn="ctr"/>
+          </a:p>
+        </p:txBody>
+      </p:sp>
+      <p:sp>
+        <p:nvSpPr>
+          <p:cNvPr id="16" name="Rectangle 15"/>
+          <p:cNvSpPr/>
+          <p:nvPr/>
+        </p:nvSpPr>
+        <p:spPr>
+          <a:xfrm>
+            <a:off x="5623560" y="5632704"/>
+            <a:ext cx="5608015" cy="548640"/>
+          </a:xfrm>
+          <a:prstGeom prst="rect">
+            <a:avLst/>
+          </a:prstGeom>
+          <a:solidFill>
+            <a:srgbClr val="FFE600"/>
+          </a:solidFill>
+          <a:ln w="25400">
+            <a:solidFill>
+              <a:srgbClr val="000000"/>
+            </a:solidFill>
+          </a:ln>
+        </p:spPr>
+        <p:style>
+          <a:lnRef idx="1">
+            <a:schemeClr val="accent1"/>
+          </a:lnRef>
+          <a:fillRef idx="3">
+            <a:schemeClr val="accent1"/>
+          </a:fillRef>
+          <a:effectRef idx="2">
+            <a:schemeClr val="accent1"/>
+          </a:effectRef>
+          <a:fontRef idx="minor">
+            <a:schemeClr val="lt1"/>
+          </a:fontRef>
+        </p:style>
+        <p:txBody>
+          <a:bodyPr rtlCol="0" anchor="ctr"/>
+          <a:lstStyle/>
+          <a:p>
+            <a:pPr algn="ctr"/>
+          </a:p>
+        </p:txBody>
+      </p:sp>
+      <p:sp>
+        <p:nvSpPr>
+          <p:cNvPr id="17" name="TextBox 16"/>
+          <p:cNvSpPr txBox="1"/>
+          <p:nvPr/>
+        </p:nvSpPr>
+        <p:spPr>
+          <a:xfrm>
+            <a:off x="5696712" y="5660136"/>
+            <a:ext cx="5461711" cy="493776"/>
+          </a:xfrm>
+          <a:prstGeom prst="rect">
+            <a:avLst/>
+          </a:prstGeom>
+          <a:noFill/>
+        </p:spPr>
+        <p:txBody>
+          <a:bodyPr wrap="square">
+            <a:spAutoFit/>
+          </a:bodyPr>
+          <a:lstStyle/>
+          <a:p>
+            <a:r>
+              <a:rPr sz="960" b="1">
+                <a:solidFill>
+                  <a:srgbClr val="000000"/>
+                </a:solidFill>
+                <a:latin typeface="Segoe UI"/>
+                <a:hlinkClick r:id="rId2"/>
+              </a:rPr>
+              <a:t>▶ BUKA KODE LENGKAP DI GITHUB (slide_10_pubspec_yaml_simulator.dart)</a:t>
+            </a:r>
+          </a:p>
+          <a:p>
+            <a:pPr>
+              <a:defRPr sz="760">
+                <a:solidFill>
+                  <a:srgbClr val="3C3C3C"/>
+                </a:solidFill>
+                <a:latin typeface="Segoe UI"/>
+              </a:defRPr>
+            </a:pPr>
+            <a:r>
+              <a:t>💡 Buka di browser / salin source code: github.com/antonprafanto/mobile2026</a:t>
             </a:r>
           </a:p>
         </p:txBody>
@@ -4570,7 +4706,7 @@
               </a:defRPr>
             </a:pPr>
             <a:r>
-              <a:t>cheat_sheet_reload.txt  |  KODE / TERMINAL BERSIH</a:t>
+              <a:t>cheat_sheet_reload.txt  |  KODE IMPLEMENTASI</a:t>
             </a:r>
           </a:p>
         </p:txBody>
@@ -4583,8 +4719,8 @@
         </p:nvSpPr>
         <p:spPr>
           <a:xfrm>
-            <a:off x="5669280" y="2176272"/>
-            <a:ext cx="5486400" cy="3977639"/>
+            <a:off x="5669280" y="2121408"/>
+            <a:ext cx="5486400" cy="3364992"/>
           </a:xfrm>
           <a:prstGeom prst="rect">
             <a:avLst/>
@@ -4598,7 +4734,7 @@
           <a:lstStyle/>
           <a:p>
             <a:pPr>
-              <a:defRPr sz="980">
+              <a:defRPr sz="919">
                 <a:solidFill>
                   <a:srgbClr val="F5F5F5"/>
                 </a:solidFill>
@@ -4648,6 +4784,142 @@
             <a:br/>
             <a:r>
               <a:t>// Tekan 'q' -&gt; Keluar (Quit)</a:t>
+            </a:r>
+          </a:p>
+        </p:txBody>
+      </p:sp>
+      <p:sp>
+        <p:nvSpPr>
+          <p:cNvPr id="15" name="Rectangle 14"/>
+          <p:cNvSpPr/>
+          <p:nvPr/>
+        </p:nvSpPr>
+        <p:spPr>
+          <a:xfrm>
+            <a:off x="5660136" y="5669280"/>
+            <a:ext cx="5608015" cy="548640"/>
+          </a:xfrm>
+          <a:prstGeom prst="rect">
+            <a:avLst/>
+          </a:prstGeom>
+          <a:solidFill>
+            <a:srgbClr val="000000"/>
+          </a:solidFill>
+          <a:ln>
+            <a:noFill/>
+          </a:ln>
+        </p:spPr>
+        <p:style>
+          <a:lnRef idx="1">
+            <a:schemeClr val="accent1"/>
+          </a:lnRef>
+          <a:fillRef idx="3">
+            <a:schemeClr val="accent1"/>
+          </a:fillRef>
+          <a:effectRef idx="2">
+            <a:schemeClr val="accent1"/>
+          </a:effectRef>
+          <a:fontRef idx="minor">
+            <a:schemeClr val="lt1"/>
+          </a:fontRef>
+        </p:style>
+        <p:txBody>
+          <a:bodyPr rtlCol="0" anchor="ctr"/>
+          <a:lstStyle/>
+          <a:p>
+            <a:pPr algn="ctr"/>
+          </a:p>
+        </p:txBody>
+      </p:sp>
+      <p:sp>
+        <p:nvSpPr>
+          <p:cNvPr id="16" name="Rectangle 15"/>
+          <p:cNvSpPr/>
+          <p:nvPr/>
+        </p:nvSpPr>
+        <p:spPr>
+          <a:xfrm>
+            <a:off x="5623560" y="5632704"/>
+            <a:ext cx="5608015" cy="548640"/>
+          </a:xfrm>
+          <a:prstGeom prst="rect">
+            <a:avLst/>
+          </a:prstGeom>
+          <a:solidFill>
+            <a:srgbClr val="FFE600"/>
+          </a:solidFill>
+          <a:ln w="25400">
+            <a:solidFill>
+              <a:srgbClr val="000000"/>
+            </a:solidFill>
+          </a:ln>
+        </p:spPr>
+        <p:style>
+          <a:lnRef idx="1">
+            <a:schemeClr val="accent1"/>
+          </a:lnRef>
+          <a:fillRef idx="3">
+            <a:schemeClr val="accent1"/>
+          </a:fillRef>
+          <a:effectRef idx="2">
+            <a:schemeClr val="accent1"/>
+          </a:effectRef>
+          <a:fontRef idx="minor">
+            <a:schemeClr val="lt1"/>
+          </a:fontRef>
+        </p:style>
+        <p:txBody>
+          <a:bodyPr rtlCol="0" anchor="ctr"/>
+          <a:lstStyle/>
+          <a:p>
+            <a:pPr algn="ctr"/>
+          </a:p>
+        </p:txBody>
+      </p:sp>
+      <p:sp>
+        <p:nvSpPr>
+          <p:cNvPr id="17" name="TextBox 16"/>
+          <p:cNvSpPr txBox="1"/>
+          <p:nvPr/>
+        </p:nvSpPr>
+        <p:spPr>
+          <a:xfrm>
+            <a:off x="5696712" y="5660136"/>
+            <a:ext cx="5461711" cy="493776"/>
+          </a:xfrm>
+          <a:prstGeom prst="rect">
+            <a:avLst/>
+          </a:prstGeom>
+          <a:noFill/>
+        </p:spPr>
+        <p:txBody>
+          <a:bodyPr wrap="square">
+            <a:spAutoFit/>
+          </a:bodyPr>
+          <a:lstStyle/>
+          <a:p>
+            <a:r>
+              <a:rPr sz="960" b="1">
+                <a:solidFill>
+                  <a:srgbClr val="000000"/>
+                </a:solidFill>
+                <a:latin typeface="Segoe UI"/>
+                <a:hlinkClick r:id="rId2"/>
+              </a:rPr>
+              <a:t>▶ BUKA KODE LENGKAP DI GITHUB (slide_11_hot_reload_vs_restart.dart)</a:t>
+            </a:r>
+          </a:p>
+          <a:p>
+            <a:pPr>
+              <a:defRPr sz="760">
+                <a:solidFill>
+                  <a:srgbClr val="3C3C3C"/>
+                </a:solidFill>
+                <a:latin typeface="Segoe UI"/>
+              </a:defRPr>
+            </a:pPr>
+            <a:r>
+              <a:t>💡 Buka di browser / salin source code: github.com/antonprafanto/mobile2026</a:t>
             </a:r>
           </a:p>
         </p:txBody>
@@ -5257,7 +5529,7 @@
               </a:defRPr>
             </a:pPr>
             <a:r>
-              <a:t>main_minimal.dart  |  KODE / TERMINAL BERSIH</a:t>
+              <a:t>main_minimal.dart  |  KODE IMPLEMENTASI</a:t>
             </a:r>
           </a:p>
         </p:txBody>
@@ -5270,8 +5542,8 @@
         </p:nvSpPr>
         <p:spPr>
           <a:xfrm>
-            <a:off x="5669280" y="2176272"/>
-            <a:ext cx="5486400" cy="3977639"/>
+            <a:off x="5669280" y="2121408"/>
+            <a:ext cx="5486400" cy="3364992"/>
           </a:xfrm>
           <a:prstGeom prst="rect">
             <a:avLst/>
@@ -5285,7 +5557,7 @@
           <a:lstStyle/>
           <a:p>
             <a:pPr>
-              <a:defRPr sz="980">
+              <a:defRPr sz="919">
                 <a:solidFill>
                   <a:srgbClr val="F5F5F5"/>
                 </a:solidFill>
@@ -5381,6 +5653,142 @@
             <a:br/>
             <a:r>
               <a:t>}</a:t>
+            </a:r>
+          </a:p>
+        </p:txBody>
+      </p:sp>
+      <p:sp>
+        <p:nvSpPr>
+          <p:cNvPr id="15" name="Rectangle 14"/>
+          <p:cNvSpPr/>
+          <p:nvPr/>
+        </p:nvSpPr>
+        <p:spPr>
+          <a:xfrm>
+            <a:off x="5660136" y="5669280"/>
+            <a:ext cx="5608015" cy="548640"/>
+          </a:xfrm>
+          <a:prstGeom prst="rect">
+            <a:avLst/>
+          </a:prstGeom>
+          <a:solidFill>
+            <a:srgbClr val="000000"/>
+          </a:solidFill>
+          <a:ln>
+            <a:noFill/>
+          </a:ln>
+        </p:spPr>
+        <p:style>
+          <a:lnRef idx="1">
+            <a:schemeClr val="accent1"/>
+          </a:lnRef>
+          <a:fillRef idx="3">
+            <a:schemeClr val="accent1"/>
+          </a:fillRef>
+          <a:effectRef idx="2">
+            <a:schemeClr val="accent1"/>
+          </a:effectRef>
+          <a:fontRef idx="minor">
+            <a:schemeClr val="lt1"/>
+          </a:fontRef>
+        </p:style>
+        <p:txBody>
+          <a:bodyPr rtlCol="0" anchor="ctr"/>
+          <a:lstStyle/>
+          <a:p>
+            <a:pPr algn="ctr"/>
+          </a:p>
+        </p:txBody>
+      </p:sp>
+      <p:sp>
+        <p:nvSpPr>
+          <p:cNvPr id="16" name="Rectangle 15"/>
+          <p:cNvSpPr/>
+          <p:nvPr/>
+        </p:nvSpPr>
+        <p:spPr>
+          <a:xfrm>
+            <a:off x="5623560" y="5632704"/>
+            <a:ext cx="5608015" cy="548640"/>
+          </a:xfrm>
+          <a:prstGeom prst="rect">
+            <a:avLst/>
+          </a:prstGeom>
+          <a:solidFill>
+            <a:srgbClr val="FFE600"/>
+          </a:solidFill>
+          <a:ln w="25400">
+            <a:solidFill>
+              <a:srgbClr val="000000"/>
+            </a:solidFill>
+          </a:ln>
+        </p:spPr>
+        <p:style>
+          <a:lnRef idx="1">
+            <a:schemeClr val="accent1"/>
+          </a:lnRef>
+          <a:fillRef idx="3">
+            <a:schemeClr val="accent1"/>
+          </a:fillRef>
+          <a:effectRef idx="2">
+            <a:schemeClr val="accent1"/>
+          </a:effectRef>
+          <a:fontRef idx="minor">
+            <a:schemeClr val="lt1"/>
+          </a:fontRef>
+        </p:style>
+        <p:txBody>
+          <a:bodyPr rtlCol="0" anchor="ctr"/>
+          <a:lstStyle/>
+          <a:p>
+            <a:pPr algn="ctr"/>
+          </a:p>
+        </p:txBody>
+      </p:sp>
+      <p:sp>
+        <p:nvSpPr>
+          <p:cNvPr id="17" name="TextBox 16"/>
+          <p:cNvSpPr txBox="1"/>
+          <p:nvPr/>
+        </p:nvSpPr>
+        <p:spPr>
+          <a:xfrm>
+            <a:off x="5696712" y="5660136"/>
+            <a:ext cx="5461711" cy="493776"/>
+          </a:xfrm>
+          <a:prstGeom prst="rect">
+            <a:avLst/>
+          </a:prstGeom>
+          <a:noFill/>
+        </p:spPr>
+        <p:txBody>
+          <a:bodyPr wrap="square">
+            <a:spAutoFit/>
+          </a:bodyPr>
+          <a:lstStyle/>
+          <a:p>
+            <a:r>
+              <a:rPr sz="960" b="1">
+                <a:solidFill>
+                  <a:srgbClr val="000000"/>
+                </a:solidFill>
+                <a:latin typeface="Segoe UI"/>
+                <a:hlinkClick r:id="rId2"/>
+              </a:rPr>
+              <a:t>▶ BUKA KODE LENGKAP DI GITHUB (slide_12_hello_flutter_minimal.dart)</a:t>
+            </a:r>
+          </a:p>
+          <a:p>
+            <a:pPr>
+              <a:defRPr sz="760">
+                <a:solidFill>
+                  <a:srgbClr val="3C3C3C"/>
+                </a:solidFill>
+                <a:latin typeface="Segoe UI"/>
+              </a:defRPr>
+            </a:pPr>
+            <a:r>
+              <a:t>💡 Buka di browser / salin source code: github.com/antonprafanto/mobile2026</a:t>
             </a:r>
           </a:p>
         </p:txBody>
@@ -5974,7 +6382,7 @@
               </a:defRPr>
             </a:pPr>
             <a:r>
-              <a:t>counter_logic.dart  |  KODE / TERMINAL BERSIH</a:t>
+              <a:t>counter_logic.dart  |  KODE IMPLEMENTASI</a:t>
             </a:r>
           </a:p>
         </p:txBody>
@@ -5987,8 +6395,8 @@
         </p:nvSpPr>
         <p:spPr>
           <a:xfrm>
-            <a:off x="5669280" y="2176272"/>
-            <a:ext cx="5486400" cy="3977639"/>
+            <a:off x="5669280" y="2121408"/>
+            <a:ext cx="5486400" cy="3364992"/>
           </a:xfrm>
           <a:prstGeom prst="rect">
             <a:avLst/>
@@ -6002,7 +6410,7 @@
           <a:lstStyle/>
           <a:p>
             <a:pPr>
-              <a:defRPr sz="980">
+              <a:defRPr sz="919">
                 <a:solidFill>
                   <a:srgbClr val="F5F5F5"/>
                 </a:solidFill>
@@ -6078,6 +6486,142 @@
             <a:br/>
             <a:r>
               <a:t>);</a:t>
+            </a:r>
+          </a:p>
+        </p:txBody>
+      </p:sp>
+      <p:sp>
+        <p:nvSpPr>
+          <p:cNvPr id="15" name="Rectangle 14"/>
+          <p:cNvSpPr/>
+          <p:nvPr/>
+        </p:nvSpPr>
+        <p:spPr>
+          <a:xfrm>
+            <a:off x="5660136" y="5669280"/>
+            <a:ext cx="5608015" cy="548640"/>
+          </a:xfrm>
+          <a:prstGeom prst="rect">
+            <a:avLst/>
+          </a:prstGeom>
+          <a:solidFill>
+            <a:srgbClr val="000000"/>
+          </a:solidFill>
+          <a:ln>
+            <a:noFill/>
+          </a:ln>
+        </p:spPr>
+        <p:style>
+          <a:lnRef idx="1">
+            <a:schemeClr val="accent1"/>
+          </a:lnRef>
+          <a:fillRef idx="3">
+            <a:schemeClr val="accent1"/>
+          </a:fillRef>
+          <a:effectRef idx="2">
+            <a:schemeClr val="accent1"/>
+          </a:effectRef>
+          <a:fontRef idx="minor">
+            <a:schemeClr val="lt1"/>
+          </a:fontRef>
+        </p:style>
+        <p:txBody>
+          <a:bodyPr rtlCol="0" anchor="ctr"/>
+          <a:lstStyle/>
+          <a:p>
+            <a:pPr algn="ctr"/>
+          </a:p>
+        </p:txBody>
+      </p:sp>
+      <p:sp>
+        <p:nvSpPr>
+          <p:cNvPr id="16" name="Rectangle 15"/>
+          <p:cNvSpPr/>
+          <p:nvPr/>
+        </p:nvSpPr>
+        <p:spPr>
+          <a:xfrm>
+            <a:off x="5623560" y="5632704"/>
+            <a:ext cx="5608015" cy="548640"/>
+          </a:xfrm>
+          <a:prstGeom prst="rect">
+            <a:avLst/>
+          </a:prstGeom>
+          <a:solidFill>
+            <a:srgbClr val="FFE600"/>
+          </a:solidFill>
+          <a:ln w="25400">
+            <a:solidFill>
+              <a:srgbClr val="000000"/>
+            </a:solidFill>
+          </a:ln>
+        </p:spPr>
+        <p:style>
+          <a:lnRef idx="1">
+            <a:schemeClr val="accent1"/>
+          </a:lnRef>
+          <a:fillRef idx="3">
+            <a:schemeClr val="accent1"/>
+          </a:fillRef>
+          <a:effectRef idx="2">
+            <a:schemeClr val="accent1"/>
+          </a:effectRef>
+          <a:fontRef idx="minor">
+            <a:schemeClr val="lt1"/>
+          </a:fontRef>
+        </p:style>
+        <p:txBody>
+          <a:bodyPr rtlCol="0" anchor="ctr"/>
+          <a:lstStyle/>
+          <a:p>
+            <a:pPr algn="ctr"/>
+          </a:p>
+        </p:txBody>
+      </p:sp>
+      <p:sp>
+        <p:nvSpPr>
+          <p:cNvPr id="17" name="TextBox 16"/>
+          <p:cNvSpPr txBox="1"/>
+          <p:nvPr/>
+        </p:nvSpPr>
+        <p:spPr>
+          <a:xfrm>
+            <a:off x="5696712" y="5660136"/>
+            <a:ext cx="5461711" cy="493776"/>
+          </a:xfrm>
+          <a:prstGeom prst="rect">
+            <a:avLst/>
+          </a:prstGeom>
+          <a:noFill/>
+        </p:spPr>
+        <p:txBody>
+          <a:bodyPr wrap="square">
+            <a:spAutoFit/>
+          </a:bodyPr>
+          <a:lstStyle/>
+          <a:p>
+            <a:r>
+              <a:rPr sz="960" b="1">
+                <a:solidFill>
+                  <a:srgbClr val="000000"/>
+                </a:solidFill>
+                <a:latin typeface="Segoe UI"/>
+                <a:hlinkClick r:id="rId2"/>
+              </a:rPr>
+              <a:t>▶ BUKA KODE LENGKAP DI GITHUB (slide_13_counter_app_deepdive.dart)</a:t>
+            </a:r>
+          </a:p>
+          <a:p>
+            <a:pPr>
+              <a:defRPr sz="760">
+                <a:solidFill>
+                  <a:srgbClr val="3C3C3C"/>
+                </a:solidFill>
+                <a:latin typeface="Segoe UI"/>
+              </a:defRPr>
+            </a:pPr>
+            <a:r>
+              <a:t>💡 Buka di browser / salin source code: github.com/antonprafanto/mobile2026</a:t>
             </a:r>
           </a:p>
         </p:txBody>
@@ -6655,7 +7199,7 @@
               </a:defRPr>
             </a:pPr>
             <a:r>
-              <a:t>run_chrome.sh  |  KODE / TERMINAL BERSIH</a:t>
+              <a:t>run_chrome.sh  |  KODE IMPLEMENTASI</a:t>
             </a:r>
           </a:p>
         </p:txBody>
@@ -6668,8 +7212,8 @@
         </p:nvSpPr>
         <p:spPr>
           <a:xfrm>
-            <a:off x="5669280" y="2176272"/>
-            <a:ext cx="5486400" cy="3977639"/>
+            <a:off x="5669280" y="2121408"/>
+            <a:ext cx="5486400" cy="3364992"/>
           </a:xfrm>
           <a:prstGeom prst="rect">
             <a:avLst/>
@@ -6683,7 +7227,7 @@
           <a:lstStyle/>
           <a:p>
             <a:pPr>
-              <a:defRPr sz="980">
+              <a:defRPr sz="919">
                 <a:solidFill>
                   <a:srgbClr val="F5F5F5"/>
                 </a:solidFill>
@@ -6723,6 +7267,142 @@
             <a:br/>
             <a:r>
               <a:t># Tekan F5 di VS Code -&gt; Pilih browser 'Chrome'</a:t>
+            </a:r>
+          </a:p>
+        </p:txBody>
+      </p:sp>
+      <p:sp>
+        <p:nvSpPr>
+          <p:cNvPr id="15" name="Rectangle 14"/>
+          <p:cNvSpPr/>
+          <p:nvPr/>
+        </p:nvSpPr>
+        <p:spPr>
+          <a:xfrm>
+            <a:off x="5660136" y="5669280"/>
+            <a:ext cx="5608015" cy="548640"/>
+          </a:xfrm>
+          <a:prstGeom prst="rect">
+            <a:avLst/>
+          </a:prstGeom>
+          <a:solidFill>
+            <a:srgbClr val="000000"/>
+          </a:solidFill>
+          <a:ln>
+            <a:noFill/>
+          </a:ln>
+        </p:spPr>
+        <p:style>
+          <a:lnRef idx="1">
+            <a:schemeClr val="accent1"/>
+          </a:lnRef>
+          <a:fillRef idx="3">
+            <a:schemeClr val="accent1"/>
+          </a:fillRef>
+          <a:effectRef idx="2">
+            <a:schemeClr val="accent1"/>
+          </a:effectRef>
+          <a:fontRef idx="minor">
+            <a:schemeClr val="lt1"/>
+          </a:fontRef>
+        </p:style>
+        <p:txBody>
+          <a:bodyPr rtlCol="0" anchor="ctr"/>
+          <a:lstStyle/>
+          <a:p>
+            <a:pPr algn="ctr"/>
+          </a:p>
+        </p:txBody>
+      </p:sp>
+      <p:sp>
+        <p:nvSpPr>
+          <p:cNvPr id="16" name="Rectangle 15"/>
+          <p:cNvSpPr/>
+          <p:nvPr/>
+        </p:nvSpPr>
+        <p:spPr>
+          <a:xfrm>
+            <a:off x="5623560" y="5632704"/>
+            <a:ext cx="5608015" cy="548640"/>
+          </a:xfrm>
+          <a:prstGeom prst="rect">
+            <a:avLst/>
+          </a:prstGeom>
+          <a:solidFill>
+            <a:srgbClr val="FFE600"/>
+          </a:solidFill>
+          <a:ln w="25400">
+            <a:solidFill>
+              <a:srgbClr val="000000"/>
+            </a:solidFill>
+          </a:ln>
+        </p:spPr>
+        <p:style>
+          <a:lnRef idx="1">
+            <a:schemeClr val="accent1"/>
+          </a:lnRef>
+          <a:fillRef idx="3">
+            <a:schemeClr val="accent1"/>
+          </a:fillRef>
+          <a:effectRef idx="2">
+            <a:schemeClr val="accent1"/>
+          </a:effectRef>
+          <a:fontRef idx="minor">
+            <a:schemeClr val="lt1"/>
+          </a:fontRef>
+        </p:style>
+        <p:txBody>
+          <a:bodyPr rtlCol="0" anchor="ctr"/>
+          <a:lstStyle/>
+          <a:p>
+            <a:pPr algn="ctr"/>
+          </a:p>
+        </p:txBody>
+      </p:sp>
+      <p:sp>
+        <p:nvSpPr>
+          <p:cNvPr id="17" name="TextBox 16"/>
+          <p:cNvSpPr txBox="1"/>
+          <p:nvPr/>
+        </p:nvSpPr>
+        <p:spPr>
+          <a:xfrm>
+            <a:off x="5696712" y="5660136"/>
+            <a:ext cx="5461711" cy="493776"/>
+          </a:xfrm>
+          <a:prstGeom prst="rect">
+            <a:avLst/>
+          </a:prstGeom>
+          <a:noFill/>
+        </p:spPr>
+        <p:txBody>
+          <a:bodyPr wrap="square">
+            <a:spAutoFit/>
+          </a:bodyPr>
+          <a:lstStyle/>
+          <a:p>
+            <a:r>
+              <a:rPr sz="960" b="1">
+                <a:solidFill>
+                  <a:srgbClr val="000000"/>
+                </a:solidFill>
+                <a:latin typeface="Segoe UI"/>
+                <a:hlinkClick r:id="rId2"/>
+              </a:rPr>
+              <a:t>▶ BUKA KODE LENGKAP DI GITHUB (slide_14_chrome_preview_frame.dart)</a:t>
+            </a:r>
+          </a:p>
+          <a:p>
+            <a:pPr>
+              <a:defRPr sz="760">
+                <a:solidFill>
+                  <a:srgbClr val="3C3C3C"/>
+                </a:solidFill>
+                <a:latin typeface="Segoe UI"/>
+              </a:defRPr>
+            </a:pPr>
+            <a:r>
+              <a:t>💡 Buka di browser / salin source code: github.com/antonprafanto/mobile2026</a:t>
             </a:r>
           </a:p>
         </p:txBody>
@@ -7316,7 +7996,7 @@
               </a:defRPr>
             </a:pPr>
             <a:r>
-              <a:t>setup_scrcpy.sh  |  KODE / TERMINAL BERSIH</a:t>
+              <a:t>setup_scrcpy.sh  |  KODE IMPLEMENTASI</a:t>
             </a:r>
           </a:p>
         </p:txBody>
@@ -7329,8 +8009,8 @@
         </p:nvSpPr>
         <p:spPr>
           <a:xfrm>
-            <a:off x="5669280" y="2176272"/>
-            <a:ext cx="5486400" cy="3977639"/>
+            <a:off x="5669280" y="2121408"/>
+            <a:ext cx="5486400" cy="3364992"/>
           </a:xfrm>
           <a:prstGeom prst="rect">
             <a:avLst/>
@@ -7344,7 +8024,7 @@
           <a:lstStyle/>
           <a:p>
             <a:pPr>
-              <a:defRPr sz="980">
+              <a:defRPr sz="919">
                 <a:solidFill>
                   <a:srgbClr val="F5F5F5"/>
                 </a:solidFill>
@@ -7384,6 +8064,142 @@
             <a:br/>
             <a:r>
               <a:t># mouse &amp; keyboard komputer sambil merasakan performa asli!</a:t>
+            </a:r>
+          </a:p>
+        </p:txBody>
+      </p:sp>
+      <p:sp>
+        <p:nvSpPr>
+          <p:cNvPr id="15" name="Rectangle 14"/>
+          <p:cNvSpPr/>
+          <p:nvPr/>
+        </p:nvSpPr>
+        <p:spPr>
+          <a:xfrm>
+            <a:off x="5660136" y="5669280"/>
+            <a:ext cx="5608015" cy="548640"/>
+          </a:xfrm>
+          <a:prstGeom prst="rect">
+            <a:avLst/>
+          </a:prstGeom>
+          <a:solidFill>
+            <a:srgbClr val="000000"/>
+          </a:solidFill>
+          <a:ln>
+            <a:noFill/>
+          </a:ln>
+        </p:spPr>
+        <p:style>
+          <a:lnRef idx="1">
+            <a:schemeClr val="accent1"/>
+          </a:lnRef>
+          <a:fillRef idx="3">
+            <a:schemeClr val="accent1"/>
+          </a:fillRef>
+          <a:effectRef idx="2">
+            <a:schemeClr val="accent1"/>
+          </a:effectRef>
+          <a:fontRef idx="minor">
+            <a:schemeClr val="lt1"/>
+          </a:fontRef>
+        </p:style>
+        <p:txBody>
+          <a:bodyPr rtlCol="0" anchor="ctr"/>
+          <a:lstStyle/>
+          <a:p>
+            <a:pPr algn="ctr"/>
+          </a:p>
+        </p:txBody>
+      </p:sp>
+      <p:sp>
+        <p:nvSpPr>
+          <p:cNvPr id="16" name="Rectangle 15"/>
+          <p:cNvSpPr/>
+          <p:nvPr/>
+        </p:nvSpPr>
+        <p:spPr>
+          <a:xfrm>
+            <a:off x="5623560" y="5632704"/>
+            <a:ext cx="5608015" cy="548640"/>
+          </a:xfrm>
+          <a:prstGeom prst="rect">
+            <a:avLst/>
+          </a:prstGeom>
+          <a:solidFill>
+            <a:srgbClr val="FFE600"/>
+          </a:solidFill>
+          <a:ln w="25400">
+            <a:solidFill>
+              <a:srgbClr val="000000"/>
+            </a:solidFill>
+          </a:ln>
+        </p:spPr>
+        <p:style>
+          <a:lnRef idx="1">
+            <a:schemeClr val="accent1"/>
+          </a:lnRef>
+          <a:fillRef idx="3">
+            <a:schemeClr val="accent1"/>
+          </a:fillRef>
+          <a:effectRef idx="2">
+            <a:schemeClr val="accent1"/>
+          </a:effectRef>
+          <a:fontRef idx="minor">
+            <a:schemeClr val="lt1"/>
+          </a:fontRef>
+        </p:style>
+        <p:txBody>
+          <a:bodyPr rtlCol="0" anchor="ctr"/>
+          <a:lstStyle/>
+          <a:p>
+            <a:pPr algn="ctr"/>
+          </a:p>
+        </p:txBody>
+      </p:sp>
+      <p:sp>
+        <p:nvSpPr>
+          <p:cNvPr id="17" name="TextBox 16"/>
+          <p:cNvSpPr txBox="1"/>
+          <p:nvPr/>
+        </p:nvSpPr>
+        <p:spPr>
+          <a:xfrm>
+            <a:off x="5696712" y="5660136"/>
+            <a:ext cx="5461711" cy="493776"/>
+          </a:xfrm>
+          <a:prstGeom prst="rect">
+            <a:avLst/>
+          </a:prstGeom>
+          <a:noFill/>
+        </p:spPr>
+        <p:txBody>
+          <a:bodyPr wrap="square">
+            <a:spAutoFit/>
+          </a:bodyPr>
+          <a:lstStyle/>
+          <a:p>
+            <a:r>
+              <a:rPr sz="960" b="1">
+                <a:solidFill>
+                  <a:srgbClr val="000000"/>
+                </a:solidFill>
+                <a:latin typeface="Segoe UI"/>
+                <a:hlinkClick r:id="rId2"/>
+              </a:rPr>
+              <a:t>▶ BUKA KODE LENGKAP DI GITHUB (slide_15_device_info_hardware.dart)</a:t>
+            </a:r>
+          </a:p>
+          <a:p>
+            <a:pPr>
+              <a:defRPr sz="760">
+                <a:solidFill>
+                  <a:srgbClr val="3C3C3C"/>
+                </a:solidFill>
+                <a:latin typeface="Segoe UI"/>
+              </a:defRPr>
+            </a:pPr>
+            <a:r>
+              <a:t>💡 Buka di browser / salin source code: github.com/antonprafanto/mobile2026</a:t>
             </a:r>
           </a:p>
         </p:txBody>
@@ -7961,7 +8777,7 @@
               </a:defRPr>
             </a:pPr>
             <a:r>
-              <a:t>settings.json  |  KODE / TERMINAL BERSIH</a:t>
+              <a:t>settings.json  |  KODE IMPLEMENTASI</a:t>
             </a:r>
           </a:p>
         </p:txBody>
@@ -7974,8 +8790,8 @@
         </p:nvSpPr>
         <p:spPr>
           <a:xfrm>
-            <a:off x="5669280" y="2176272"/>
-            <a:ext cx="5486400" cy="3977639"/>
+            <a:off x="5669280" y="2121408"/>
+            <a:ext cx="5486400" cy="3364992"/>
           </a:xfrm>
           <a:prstGeom prst="rect">
             <a:avLst/>
@@ -7989,7 +8805,7 @@
           <a:lstStyle/>
           <a:p>
             <a:pPr>
-              <a:defRPr sz="980">
+              <a:defRPr sz="919">
                 <a:solidFill>
                   <a:srgbClr val="F5F5F5"/>
                 </a:solidFill>
@@ -8046,6 +8862,142 @@
             <a:br/>
             <a:r>
               <a:t>}</a:t>
+            </a:r>
+          </a:p>
+        </p:txBody>
+      </p:sp>
+      <p:sp>
+        <p:nvSpPr>
+          <p:cNvPr id="15" name="Rectangle 14"/>
+          <p:cNvSpPr/>
+          <p:nvPr/>
+        </p:nvSpPr>
+        <p:spPr>
+          <a:xfrm>
+            <a:off x="5660136" y="5669280"/>
+            <a:ext cx="5608015" cy="548640"/>
+          </a:xfrm>
+          <a:prstGeom prst="rect">
+            <a:avLst/>
+          </a:prstGeom>
+          <a:solidFill>
+            <a:srgbClr val="000000"/>
+          </a:solidFill>
+          <a:ln>
+            <a:noFill/>
+          </a:ln>
+        </p:spPr>
+        <p:style>
+          <a:lnRef idx="1">
+            <a:schemeClr val="accent1"/>
+          </a:lnRef>
+          <a:fillRef idx="3">
+            <a:schemeClr val="accent1"/>
+          </a:fillRef>
+          <a:effectRef idx="2">
+            <a:schemeClr val="accent1"/>
+          </a:effectRef>
+          <a:fontRef idx="minor">
+            <a:schemeClr val="lt1"/>
+          </a:fontRef>
+        </p:style>
+        <p:txBody>
+          <a:bodyPr rtlCol="0" anchor="ctr"/>
+          <a:lstStyle/>
+          <a:p>
+            <a:pPr algn="ctr"/>
+          </a:p>
+        </p:txBody>
+      </p:sp>
+      <p:sp>
+        <p:nvSpPr>
+          <p:cNvPr id="16" name="Rectangle 15"/>
+          <p:cNvSpPr/>
+          <p:nvPr/>
+        </p:nvSpPr>
+        <p:spPr>
+          <a:xfrm>
+            <a:off x="5623560" y="5632704"/>
+            <a:ext cx="5608015" cy="548640"/>
+          </a:xfrm>
+          <a:prstGeom prst="rect">
+            <a:avLst/>
+          </a:prstGeom>
+          <a:solidFill>
+            <a:srgbClr val="FFE600"/>
+          </a:solidFill>
+          <a:ln w="25400">
+            <a:solidFill>
+              <a:srgbClr val="000000"/>
+            </a:solidFill>
+          </a:ln>
+        </p:spPr>
+        <p:style>
+          <a:lnRef idx="1">
+            <a:schemeClr val="accent1"/>
+          </a:lnRef>
+          <a:fillRef idx="3">
+            <a:schemeClr val="accent1"/>
+          </a:fillRef>
+          <a:effectRef idx="2">
+            <a:schemeClr val="accent1"/>
+          </a:effectRef>
+          <a:fontRef idx="minor">
+            <a:schemeClr val="lt1"/>
+          </a:fontRef>
+        </p:style>
+        <p:txBody>
+          <a:bodyPr rtlCol="0" anchor="ctr"/>
+          <a:lstStyle/>
+          <a:p>
+            <a:pPr algn="ctr"/>
+          </a:p>
+        </p:txBody>
+      </p:sp>
+      <p:sp>
+        <p:nvSpPr>
+          <p:cNvPr id="17" name="TextBox 16"/>
+          <p:cNvSpPr txBox="1"/>
+          <p:nvPr/>
+        </p:nvSpPr>
+        <p:spPr>
+          <a:xfrm>
+            <a:off x="5696712" y="5660136"/>
+            <a:ext cx="5461711" cy="493776"/>
+          </a:xfrm>
+          <a:prstGeom prst="rect">
+            <a:avLst/>
+          </a:prstGeom>
+          <a:noFill/>
+        </p:spPr>
+        <p:txBody>
+          <a:bodyPr wrap="square">
+            <a:spAutoFit/>
+          </a:bodyPr>
+          <a:lstStyle/>
+          <a:p>
+            <a:r>
+              <a:rPr sz="960" b="1">
+                <a:solidFill>
+                  <a:srgbClr val="000000"/>
+                </a:solidFill>
+                <a:latin typeface="Segoe UI"/>
+                <a:hlinkClick r:id="rId2"/>
+              </a:rPr>
+              <a:t>▶ BUKA KODE LENGKAP DI GITHUB (slide_16_vscode_shortcuts_guide.dart)</a:t>
+            </a:r>
+          </a:p>
+          <a:p>
+            <a:pPr>
+              <a:defRPr sz="760">
+                <a:solidFill>
+                  <a:srgbClr val="3C3C3C"/>
+                </a:solidFill>
+                <a:latin typeface="Segoe UI"/>
+              </a:defRPr>
+            </a:pPr>
+            <a:r>
+              <a:t>💡 Buka di browser / salin source code: github.com/antonprafanto/mobile2026</a:t>
             </a:r>
           </a:p>
         </p:txBody>
@@ -8448,8 +9400,8 @@
         </p:nvSpPr>
         <p:spPr>
           <a:xfrm>
-            <a:off x="1188720" y="2240280"/>
-            <a:ext cx="9784080" cy="3931920"/>
+            <a:off x="1188720" y="2212848"/>
+            <a:ext cx="9784080" cy="3291840"/>
           </a:xfrm>
           <a:prstGeom prst="rect">
             <a:avLst/>
@@ -8464,9 +9416,9 @@
           <a:p>
             <a:pPr>
               <a:spcAft>
-                <a:spcPts val="500"/>
+                <a:spcPts val="400"/>
               </a:spcAft>
-              <a:defRPr sz="1450" b="1">
+              <a:defRPr sz="1350" b="1">
                 <a:solidFill>
                   <a:srgbClr val="000000"/>
                 </a:solidFill>
@@ -8480,9 +9432,9 @@
           <a:p>
             <a:pPr>
               <a:spcAft>
-                <a:spcPts val="300"/>
+                <a:spcPts val="200"/>
               </a:spcAft>
-              <a:defRPr sz="1100">
+              <a:defRPr sz="1050">
                 <a:solidFill>
                   <a:srgbClr val="1E1E1E"/>
                 </a:solidFill>
@@ -8496,9 +9448,9 @@
           <a:p>
             <a:pPr>
               <a:spcAft>
-                <a:spcPts val="300"/>
+                <a:spcPts val="200"/>
               </a:spcAft>
-              <a:defRPr sz="1100">
+              <a:defRPr sz="1050">
                 <a:solidFill>
                   <a:srgbClr val="1E1E1E"/>
                 </a:solidFill>
@@ -8512,9 +9464,9 @@
           <a:p>
             <a:pPr>
               <a:spcAft>
-                <a:spcPts val="300"/>
+                <a:spcPts val="200"/>
               </a:spcAft>
-              <a:defRPr sz="1100">
+              <a:defRPr sz="1050">
                 <a:solidFill>
                   <a:srgbClr val="1E1E1E"/>
                 </a:solidFill>
@@ -8528,9 +9480,9 @@
           <a:p>
             <a:pPr>
               <a:spcAft>
-                <a:spcPts val="300"/>
+                <a:spcPts val="200"/>
               </a:spcAft>
-              <a:defRPr sz="1100">
+              <a:defRPr sz="1050">
                 <a:solidFill>
                   <a:srgbClr val="1E1E1E"/>
                 </a:solidFill>
@@ -8544,9 +9496,9 @@
           <a:p>
             <a:pPr>
               <a:spcAft>
-                <a:spcPts val="300"/>
+                <a:spcPts val="200"/>
               </a:spcAft>
-              <a:defRPr sz="1100">
+              <a:defRPr sz="1050">
                 <a:solidFill>
                   <a:srgbClr val="1E1E1E"/>
                 </a:solidFill>
@@ -8560,9 +9512,9 @@
           <a:p>
             <a:pPr>
               <a:spcAft>
-                <a:spcPts val="300"/>
+                <a:spcPts val="200"/>
               </a:spcAft>
-              <a:defRPr sz="1100">
+              <a:defRPr sz="1050">
                 <a:solidFill>
                   <a:srgbClr val="1E1E1E"/>
                 </a:solidFill>
@@ -8576,9 +9528,9 @@
           <a:p>
             <a:pPr>
               <a:spcAft>
-                <a:spcPts val="300"/>
+                <a:spcPts val="200"/>
               </a:spcAft>
-              <a:defRPr sz="1100">
+              <a:defRPr sz="1050">
                 <a:solidFill>
                   <a:srgbClr val="1E1E1E"/>
                 </a:solidFill>
@@ -8590,9 +9542,8 @@
             </a:r>
           </a:p>
           <a:p>
-            <a:br/>
-            <a:pPr>
-              <a:defRPr sz="1150" b="1">
+            <a:pPr>
+              <a:defRPr sz="1100" b="1">
                 <a:solidFill>
                   <a:srgbClr val="00823C"/>
                 </a:solidFill>
@@ -8600,11 +9551,130 @@
               </a:defRPr>
             </a:pPr>
             <a:r>
-              <a:t>✔ Kriteria Keberhasilan (Tunjukkan ke Dosen/Asisten Lab):</a:t>
-            </a:r>
-            <a:br/>
-            <a:r>
-              <a:t>Tunjukkan layar aplikasi yang menampilkan Nama, NIM, dan perubahan warna tema kepada Dosen atau Asisten Lab untuk mendapatkan checklist nilai modul 1.</a:t>
+              <a:t>✔ Kriteria Keberhasilan (Tunjukkan ke Dosen/Asisten Lab): Tunjukkan layar aplikasi yang menampilkan Nama, NIM, dan perubahan warna tema kepada Dosen atau Asisten Lab untuk mendapatkan checklist nilai modul 1.</a:t>
+            </a:r>
+          </a:p>
+        </p:txBody>
+      </p:sp>
+      <p:sp>
+        <p:nvSpPr>
+          <p:cNvPr id="12" name="Rectangle 11"/>
+          <p:cNvSpPr/>
+          <p:nvPr/>
+        </p:nvSpPr>
+        <p:spPr>
+          <a:xfrm>
+            <a:off x="1225296" y="5669280"/>
+            <a:ext cx="9784080" cy="502920"/>
+          </a:xfrm>
+          <a:prstGeom prst="rect">
+            <a:avLst/>
+          </a:prstGeom>
+          <a:solidFill>
+            <a:srgbClr val="000000"/>
+          </a:solidFill>
+          <a:ln>
+            <a:noFill/>
+          </a:ln>
+        </p:spPr>
+        <p:style>
+          <a:lnRef idx="1">
+            <a:schemeClr val="accent1"/>
+          </a:lnRef>
+          <a:fillRef idx="3">
+            <a:schemeClr val="accent1"/>
+          </a:fillRef>
+          <a:effectRef idx="2">
+            <a:schemeClr val="accent1"/>
+          </a:effectRef>
+          <a:fontRef idx="minor">
+            <a:schemeClr val="lt1"/>
+          </a:fontRef>
+        </p:style>
+        <p:txBody>
+          <a:bodyPr rtlCol="0" anchor="ctr"/>
+          <a:lstStyle/>
+          <a:p>
+            <a:pPr algn="ctr"/>
+          </a:p>
+        </p:txBody>
+      </p:sp>
+      <p:sp>
+        <p:nvSpPr>
+          <p:cNvPr id="13" name="Rectangle 12"/>
+          <p:cNvSpPr/>
+          <p:nvPr/>
+        </p:nvSpPr>
+        <p:spPr>
+          <a:xfrm>
+            <a:off x="1188720" y="5632704"/>
+            <a:ext cx="9784080" cy="502920"/>
+          </a:xfrm>
+          <a:prstGeom prst="rect">
+            <a:avLst/>
+          </a:prstGeom>
+          <a:solidFill>
+            <a:srgbClr val="4ADE80"/>
+          </a:solidFill>
+          <a:ln w="25400">
+            <a:solidFill>
+              <a:srgbClr val="000000"/>
+            </a:solidFill>
+          </a:ln>
+        </p:spPr>
+        <p:style>
+          <a:lnRef idx="1">
+            <a:schemeClr val="accent1"/>
+          </a:lnRef>
+          <a:fillRef idx="3">
+            <a:schemeClr val="accent1"/>
+          </a:fillRef>
+          <a:effectRef idx="2">
+            <a:schemeClr val="accent1"/>
+          </a:effectRef>
+          <a:fontRef idx="minor">
+            <a:schemeClr val="lt1"/>
+          </a:fontRef>
+        </p:style>
+        <p:txBody>
+          <a:bodyPr rtlCol="0" anchor="ctr"/>
+          <a:lstStyle/>
+          <a:p>
+            <a:pPr algn="ctr"/>
+          </a:p>
+        </p:txBody>
+      </p:sp>
+      <p:sp>
+        <p:nvSpPr>
+          <p:cNvPr id="14" name="TextBox 13"/>
+          <p:cNvSpPr txBox="1"/>
+          <p:nvPr/>
+        </p:nvSpPr>
+        <p:spPr>
+          <a:xfrm>
+            <a:off x="1261872" y="5660136"/>
+            <a:ext cx="9637776" cy="448056"/>
+          </a:xfrm>
+          <a:prstGeom prst="rect">
+            <a:avLst/>
+          </a:prstGeom>
+          <a:noFill/>
+        </p:spPr>
+        <p:txBody>
+          <a:bodyPr wrap="square">
+            <a:spAutoFit/>
+          </a:bodyPr>
+          <a:lstStyle/>
+          <a:p>
+            <a:r>
+              <a:rPr sz="1000" b="1">
+                <a:solidFill>
+                  <a:srgbClr val="000000"/>
+                </a:solidFill>
+                <a:latin typeface="Segoe UI"/>
+                <a:hlinkClick r:id="rId2"/>
+              </a:rPr>
+              <a:t>▶ BUKA KODE SOLUSI LENGKAP LAB QUEST DI GITHUB (slide_17_lab_quest_tugas_01.dart)</a:t>
             </a:r>
           </a:p>
         </p:txBody>
@@ -9182,7 +10252,7 @@
               </a:defRPr>
             </a:pPr>
             <a:r>
-              <a:t>preview_pertemuan_02.dart  |  KODE / TERMINAL BERSIH</a:t>
+              <a:t>preview_pertemuan_02.dart  |  KODE IMPLEMENTASI</a:t>
             </a:r>
           </a:p>
         </p:txBody>
@@ -9195,8 +10265,8 @@
         </p:nvSpPr>
         <p:spPr>
           <a:xfrm>
-            <a:off x="5669280" y="2176272"/>
-            <a:ext cx="5486400" cy="3977639"/>
+            <a:off x="5669280" y="2121408"/>
+            <a:ext cx="5486400" cy="3364992"/>
           </a:xfrm>
           <a:prstGeom prst="rect">
             <a:avLst/>
@@ -9210,7 +10280,7 @@
           <a:lstStyle/>
           <a:p>
             <a:pPr>
-              <a:defRPr sz="980">
+              <a:defRPr sz="919">
                 <a:solidFill>
                   <a:srgbClr val="F5F5F5"/>
                 </a:solidFill>
@@ -9257,6 +10327,142 @@
             <a:br/>
             <a:r>
               <a:t>}</a:t>
+            </a:r>
+          </a:p>
+        </p:txBody>
+      </p:sp>
+      <p:sp>
+        <p:nvSpPr>
+          <p:cNvPr id="15" name="Rectangle 14"/>
+          <p:cNvSpPr/>
+          <p:nvPr/>
+        </p:nvSpPr>
+        <p:spPr>
+          <a:xfrm>
+            <a:off x="5660136" y="5669280"/>
+            <a:ext cx="5608015" cy="548640"/>
+          </a:xfrm>
+          <a:prstGeom prst="rect">
+            <a:avLst/>
+          </a:prstGeom>
+          <a:solidFill>
+            <a:srgbClr val="000000"/>
+          </a:solidFill>
+          <a:ln>
+            <a:noFill/>
+          </a:ln>
+        </p:spPr>
+        <p:style>
+          <a:lnRef idx="1">
+            <a:schemeClr val="accent1"/>
+          </a:lnRef>
+          <a:fillRef idx="3">
+            <a:schemeClr val="accent1"/>
+          </a:fillRef>
+          <a:effectRef idx="2">
+            <a:schemeClr val="accent1"/>
+          </a:effectRef>
+          <a:fontRef idx="minor">
+            <a:schemeClr val="lt1"/>
+          </a:fontRef>
+        </p:style>
+        <p:txBody>
+          <a:bodyPr rtlCol="0" anchor="ctr"/>
+          <a:lstStyle/>
+          <a:p>
+            <a:pPr algn="ctr"/>
+          </a:p>
+        </p:txBody>
+      </p:sp>
+      <p:sp>
+        <p:nvSpPr>
+          <p:cNvPr id="16" name="Rectangle 15"/>
+          <p:cNvSpPr/>
+          <p:nvPr/>
+        </p:nvSpPr>
+        <p:spPr>
+          <a:xfrm>
+            <a:off x="5623560" y="5632704"/>
+            <a:ext cx="5608015" cy="548640"/>
+          </a:xfrm>
+          <a:prstGeom prst="rect">
+            <a:avLst/>
+          </a:prstGeom>
+          <a:solidFill>
+            <a:srgbClr val="FFE600"/>
+          </a:solidFill>
+          <a:ln w="25400">
+            <a:solidFill>
+              <a:srgbClr val="000000"/>
+            </a:solidFill>
+          </a:ln>
+        </p:spPr>
+        <p:style>
+          <a:lnRef idx="1">
+            <a:schemeClr val="accent1"/>
+          </a:lnRef>
+          <a:fillRef idx="3">
+            <a:schemeClr val="accent1"/>
+          </a:fillRef>
+          <a:effectRef idx="2">
+            <a:schemeClr val="accent1"/>
+          </a:effectRef>
+          <a:fontRef idx="minor">
+            <a:schemeClr val="lt1"/>
+          </a:fontRef>
+        </p:style>
+        <p:txBody>
+          <a:bodyPr rtlCol="0" anchor="ctr"/>
+          <a:lstStyle/>
+          <a:p>
+            <a:pPr algn="ctr"/>
+          </a:p>
+        </p:txBody>
+      </p:sp>
+      <p:sp>
+        <p:nvSpPr>
+          <p:cNvPr id="17" name="TextBox 16"/>
+          <p:cNvSpPr txBox="1"/>
+          <p:nvPr/>
+        </p:nvSpPr>
+        <p:spPr>
+          <a:xfrm>
+            <a:off x="5696712" y="5660136"/>
+            <a:ext cx="5461711" cy="493776"/>
+          </a:xfrm>
+          <a:prstGeom prst="rect">
+            <a:avLst/>
+          </a:prstGeom>
+          <a:noFill/>
+        </p:spPr>
+        <p:txBody>
+          <a:bodyPr wrap="square">
+            <a:spAutoFit/>
+          </a:bodyPr>
+          <a:lstStyle/>
+          <a:p>
+            <a:r>
+              <a:rPr sz="960" b="1">
+                <a:solidFill>
+                  <a:srgbClr val="000000"/>
+                </a:solidFill>
+                <a:latin typeface="Segoe UI"/>
+                <a:hlinkClick r:id="rId2"/>
+              </a:rPr>
+              <a:t>▶ BUKA KODE LENGKAP DI GITHUB (slide_18_preview_modern_dart.dart)</a:t>
+            </a:r>
+          </a:p>
+          <a:p>
+            <a:pPr>
+              <a:defRPr sz="760">
+                <a:solidFill>
+                  <a:srgbClr val="3C3C3C"/>
+                </a:solidFill>
+                <a:latin typeface="Segoe UI"/>
+              </a:defRPr>
+            </a:pPr>
+            <a:r>
+              <a:t>💡 Buka di browser / salin source code: github.com/antonprafanto/mobile2026</a:t>
             </a:r>
           </a:p>
         </p:txBody>
@@ -9850,7 +11056,7 @@
               </a:defRPr>
             </a:pPr>
             <a:r>
-              <a:t>roadmap_overview.dart  |  KODE / TERMINAL BERSIH</a:t>
+              <a:t>roadmap_overview.dart  |  KODE IMPLEMENTASI</a:t>
             </a:r>
           </a:p>
         </p:txBody>
@@ -9863,8 +11069,8 @@
         </p:nvSpPr>
         <p:spPr>
           <a:xfrm>
-            <a:off x="5669280" y="2176272"/>
-            <a:ext cx="5486400" cy="3977639"/>
+            <a:off x="5669280" y="2121408"/>
+            <a:ext cx="5486400" cy="3364992"/>
           </a:xfrm>
           <a:prstGeom prst="rect">
             <a:avLst/>
@@ -9878,7 +11084,7 @@
           <a:lstStyle/>
           <a:p>
             <a:pPr>
-              <a:defRPr sz="980">
+              <a:defRPr sz="919">
                 <a:solidFill>
                   <a:srgbClr val="F5F5F5"/>
                 </a:solidFill>
@@ -9924,6 +11130,142 @@
             <a:br/>
             <a:r>
               <a:t>// aplikasi nyata di GitHub yang siap dipamerkan!</a:t>
+            </a:r>
+          </a:p>
+        </p:txBody>
+      </p:sp>
+      <p:sp>
+        <p:nvSpPr>
+          <p:cNvPr id="15" name="Rectangle 14"/>
+          <p:cNvSpPr/>
+          <p:nvPr/>
+        </p:nvSpPr>
+        <p:spPr>
+          <a:xfrm>
+            <a:off x="5660136" y="5669280"/>
+            <a:ext cx="5608015" cy="548640"/>
+          </a:xfrm>
+          <a:prstGeom prst="rect">
+            <a:avLst/>
+          </a:prstGeom>
+          <a:solidFill>
+            <a:srgbClr val="000000"/>
+          </a:solidFill>
+          <a:ln>
+            <a:noFill/>
+          </a:ln>
+        </p:spPr>
+        <p:style>
+          <a:lnRef idx="1">
+            <a:schemeClr val="accent1"/>
+          </a:lnRef>
+          <a:fillRef idx="3">
+            <a:schemeClr val="accent1"/>
+          </a:fillRef>
+          <a:effectRef idx="2">
+            <a:schemeClr val="accent1"/>
+          </a:effectRef>
+          <a:fontRef idx="minor">
+            <a:schemeClr val="lt1"/>
+          </a:fontRef>
+        </p:style>
+        <p:txBody>
+          <a:bodyPr rtlCol="0" anchor="ctr"/>
+          <a:lstStyle/>
+          <a:p>
+            <a:pPr algn="ctr"/>
+          </a:p>
+        </p:txBody>
+      </p:sp>
+      <p:sp>
+        <p:nvSpPr>
+          <p:cNvPr id="16" name="Rectangle 15"/>
+          <p:cNvSpPr/>
+          <p:nvPr/>
+        </p:nvSpPr>
+        <p:spPr>
+          <a:xfrm>
+            <a:off x="5623560" y="5632704"/>
+            <a:ext cx="5608015" cy="548640"/>
+          </a:xfrm>
+          <a:prstGeom prst="rect">
+            <a:avLst/>
+          </a:prstGeom>
+          <a:solidFill>
+            <a:srgbClr val="FFE600"/>
+          </a:solidFill>
+          <a:ln w="25400">
+            <a:solidFill>
+              <a:srgbClr val="000000"/>
+            </a:solidFill>
+          </a:ln>
+        </p:spPr>
+        <p:style>
+          <a:lnRef idx="1">
+            <a:schemeClr val="accent1"/>
+          </a:lnRef>
+          <a:fillRef idx="3">
+            <a:schemeClr val="accent1"/>
+          </a:fillRef>
+          <a:effectRef idx="2">
+            <a:schemeClr val="accent1"/>
+          </a:effectRef>
+          <a:fontRef idx="minor">
+            <a:schemeClr val="lt1"/>
+          </a:fontRef>
+        </p:style>
+        <p:txBody>
+          <a:bodyPr rtlCol="0" anchor="ctr"/>
+          <a:lstStyle/>
+          <a:p>
+            <a:pPr algn="ctr"/>
+          </a:p>
+        </p:txBody>
+      </p:sp>
+      <p:sp>
+        <p:nvSpPr>
+          <p:cNvPr id="17" name="TextBox 16"/>
+          <p:cNvSpPr txBox="1"/>
+          <p:nvPr/>
+        </p:nvSpPr>
+        <p:spPr>
+          <a:xfrm>
+            <a:off x="5696712" y="5660136"/>
+            <a:ext cx="5461711" cy="493776"/>
+          </a:xfrm>
+          <a:prstGeom prst="rect">
+            <a:avLst/>
+          </a:prstGeom>
+          <a:noFill/>
+        </p:spPr>
+        <p:txBody>
+          <a:bodyPr wrap="square">
+            <a:spAutoFit/>
+          </a:bodyPr>
+          <a:lstStyle/>
+          <a:p>
+            <a:r>
+              <a:rPr sz="960" b="1">
+                <a:solidFill>
+                  <a:srgbClr val="000000"/>
+                </a:solidFill>
+                <a:latin typeface="Segoe UI"/>
+                <a:hlinkClick r:id="rId2"/>
+              </a:rPr>
+              <a:t>▶ BUKA KODE LENGKAP DI GITHUB (slide_02_roadmap_semester.dart)</a:t>
+            </a:r>
+          </a:p>
+          <a:p>
+            <a:pPr>
+              <a:defRPr sz="760">
+                <a:solidFill>
+                  <a:srgbClr val="3C3C3C"/>
+                </a:solidFill>
+                <a:latin typeface="Segoe UI"/>
+              </a:defRPr>
+            </a:pPr>
+            <a:r>
+              <a:t>💡 Buka di browser / salin source code: github.com/antonprafanto/mobile2026</a:t>
             </a:r>
           </a:p>
         </p:txBody>
@@ -10517,7 +11859,7 @@
               </a:defRPr>
             </a:pPr>
             <a:r>
-              <a:t>industri_komparasi.dart  |  KODE / TERMINAL BERSIH</a:t>
+              <a:t>industri_komparasi.dart  |  KODE IMPLEMENTASI</a:t>
             </a:r>
           </a:p>
         </p:txBody>
@@ -10530,8 +11872,8 @@
         </p:nvSpPr>
         <p:spPr>
           <a:xfrm>
-            <a:off x="5669280" y="2176272"/>
-            <a:ext cx="5486400" cy="3977639"/>
+            <a:off x="5669280" y="2121408"/>
+            <a:ext cx="5486400" cy="3364992"/>
           </a:xfrm>
           <a:prstGeom prst="rect">
             <a:avLst/>
@@ -10545,7 +11887,7 @@
           <a:lstStyle/>
           <a:p>
             <a:pPr>
-              <a:defRPr sz="980">
+              <a:defRPr sz="919">
                 <a:solidFill>
                   <a:srgbClr val="F5F5F5"/>
                 </a:solidFill>
@@ -10583,6 +11925,142 @@
             <a:br/>
             <a:r>
               <a:t>// Output: Rilis serentak di Android &amp; App Store!</a:t>
+            </a:r>
+          </a:p>
+        </p:txBody>
+      </p:sp>
+      <p:sp>
+        <p:nvSpPr>
+          <p:cNvPr id="15" name="Rectangle 14"/>
+          <p:cNvSpPr/>
+          <p:nvPr/>
+        </p:nvSpPr>
+        <p:spPr>
+          <a:xfrm>
+            <a:off x="5660136" y="5669280"/>
+            <a:ext cx="5608015" cy="548640"/>
+          </a:xfrm>
+          <a:prstGeom prst="rect">
+            <a:avLst/>
+          </a:prstGeom>
+          <a:solidFill>
+            <a:srgbClr val="000000"/>
+          </a:solidFill>
+          <a:ln>
+            <a:noFill/>
+          </a:ln>
+        </p:spPr>
+        <p:style>
+          <a:lnRef idx="1">
+            <a:schemeClr val="accent1"/>
+          </a:lnRef>
+          <a:fillRef idx="3">
+            <a:schemeClr val="accent1"/>
+          </a:fillRef>
+          <a:effectRef idx="2">
+            <a:schemeClr val="accent1"/>
+          </a:effectRef>
+          <a:fontRef idx="minor">
+            <a:schemeClr val="lt1"/>
+          </a:fontRef>
+        </p:style>
+        <p:txBody>
+          <a:bodyPr rtlCol="0" anchor="ctr"/>
+          <a:lstStyle/>
+          <a:p>
+            <a:pPr algn="ctr"/>
+          </a:p>
+        </p:txBody>
+      </p:sp>
+      <p:sp>
+        <p:nvSpPr>
+          <p:cNvPr id="16" name="Rectangle 15"/>
+          <p:cNvSpPr/>
+          <p:nvPr/>
+        </p:nvSpPr>
+        <p:spPr>
+          <a:xfrm>
+            <a:off x="5623560" y="5632704"/>
+            <a:ext cx="5608015" cy="548640"/>
+          </a:xfrm>
+          <a:prstGeom prst="rect">
+            <a:avLst/>
+          </a:prstGeom>
+          <a:solidFill>
+            <a:srgbClr val="FFE600"/>
+          </a:solidFill>
+          <a:ln w="25400">
+            <a:solidFill>
+              <a:srgbClr val="000000"/>
+            </a:solidFill>
+          </a:ln>
+        </p:spPr>
+        <p:style>
+          <a:lnRef idx="1">
+            <a:schemeClr val="accent1"/>
+          </a:lnRef>
+          <a:fillRef idx="3">
+            <a:schemeClr val="accent1"/>
+          </a:fillRef>
+          <a:effectRef idx="2">
+            <a:schemeClr val="accent1"/>
+          </a:effectRef>
+          <a:fontRef idx="minor">
+            <a:schemeClr val="lt1"/>
+          </a:fontRef>
+        </p:style>
+        <p:txBody>
+          <a:bodyPr rtlCol="0" anchor="ctr"/>
+          <a:lstStyle/>
+          <a:p>
+            <a:pPr algn="ctr"/>
+          </a:p>
+        </p:txBody>
+      </p:sp>
+      <p:sp>
+        <p:nvSpPr>
+          <p:cNvPr id="17" name="TextBox 16"/>
+          <p:cNvSpPr txBox="1"/>
+          <p:nvPr/>
+        </p:nvSpPr>
+        <p:spPr>
+          <a:xfrm>
+            <a:off x="5696712" y="5660136"/>
+            <a:ext cx="5461711" cy="493776"/>
+          </a:xfrm>
+          <a:prstGeom prst="rect">
+            <a:avLst/>
+          </a:prstGeom>
+          <a:noFill/>
+        </p:spPr>
+        <p:txBody>
+          <a:bodyPr wrap="square">
+            <a:spAutoFit/>
+          </a:bodyPr>
+          <a:lstStyle/>
+          <a:p>
+            <a:r>
+              <a:rPr sz="960" b="1">
+                <a:solidFill>
+                  <a:srgbClr val="000000"/>
+                </a:solidFill>
+                <a:latin typeface="Segoe UI"/>
+                <a:hlinkClick r:id="rId2"/>
+              </a:rPr>
+              <a:t>▶ BUKA KODE LENGKAP DI GITHUB (slide_03_relevansi_mobile.dart)</a:t>
+            </a:r>
+          </a:p>
+          <a:p>
+            <a:pPr>
+              <a:defRPr sz="760">
+                <a:solidFill>
+                  <a:srgbClr val="3C3C3C"/>
+                </a:solidFill>
+                <a:latin typeface="Segoe UI"/>
+              </a:defRPr>
+            </a:pPr>
+            <a:r>
+              <a:t>💡 Buka di browser / salin source code: github.com/antonprafanto/mobile2026</a:t>
             </a:r>
           </a:p>
         </p:txBody>
@@ -11176,7 +12654,7 @@
               </a:defRPr>
             </a:pPr>
             <a:r>
-              <a:t>dart_vs_flutter.dart  |  KODE / TERMINAL BERSIH</a:t>
+              <a:t>dart_vs_flutter.dart  |  KODE IMPLEMENTASI</a:t>
             </a:r>
           </a:p>
         </p:txBody>
@@ -11189,8 +12667,8 @@
         </p:nvSpPr>
         <p:spPr>
           <a:xfrm>
-            <a:off x="5669280" y="2176272"/>
-            <a:ext cx="5486400" cy="3977639"/>
+            <a:off x="5669280" y="2121408"/>
+            <a:ext cx="5486400" cy="3364992"/>
           </a:xfrm>
           <a:prstGeom prst="rect">
             <a:avLst/>
@@ -11204,7 +12682,7 @@
           <a:lstStyle/>
           <a:p>
             <a:pPr>
-              <a:defRPr sz="980">
+              <a:defRPr sz="919">
                 <a:solidFill>
                   <a:srgbClr val="F5F5F5"/>
                 </a:solidFill>
@@ -11254,6 +12732,142 @@
             <a:br/>
             <a:r>
               <a:t>)</a:t>
+            </a:r>
+          </a:p>
+        </p:txBody>
+      </p:sp>
+      <p:sp>
+        <p:nvSpPr>
+          <p:cNvPr id="15" name="Rectangle 14"/>
+          <p:cNvSpPr/>
+          <p:nvPr/>
+        </p:nvSpPr>
+        <p:spPr>
+          <a:xfrm>
+            <a:off x="5660136" y="5669280"/>
+            <a:ext cx="5608015" cy="548640"/>
+          </a:xfrm>
+          <a:prstGeom prst="rect">
+            <a:avLst/>
+          </a:prstGeom>
+          <a:solidFill>
+            <a:srgbClr val="000000"/>
+          </a:solidFill>
+          <a:ln>
+            <a:noFill/>
+          </a:ln>
+        </p:spPr>
+        <p:style>
+          <a:lnRef idx="1">
+            <a:schemeClr val="accent1"/>
+          </a:lnRef>
+          <a:fillRef idx="3">
+            <a:schemeClr val="accent1"/>
+          </a:fillRef>
+          <a:effectRef idx="2">
+            <a:schemeClr val="accent1"/>
+          </a:effectRef>
+          <a:fontRef idx="minor">
+            <a:schemeClr val="lt1"/>
+          </a:fontRef>
+        </p:style>
+        <p:txBody>
+          <a:bodyPr rtlCol="0" anchor="ctr"/>
+          <a:lstStyle/>
+          <a:p>
+            <a:pPr algn="ctr"/>
+          </a:p>
+        </p:txBody>
+      </p:sp>
+      <p:sp>
+        <p:nvSpPr>
+          <p:cNvPr id="16" name="Rectangle 15"/>
+          <p:cNvSpPr/>
+          <p:nvPr/>
+        </p:nvSpPr>
+        <p:spPr>
+          <a:xfrm>
+            <a:off x="5623560" y="5632704"/>
+            <a:ext cx="5608015" cy="548640"/>
+          </a:xfrm>
+          <a:prstGeom prst="rect">
+            <a:avLst/>
+          </a:prstGeom>
+          <a:solidFill>
+            <a:srgbClr val="FFE600"/>
+          </a:solidFill>
+          <a:ln w="25400">
+            <a:solidFill>
+              <a:srgbClr val="000000"/>
+            </a:solidFill>
+          </a:ln>
+        </p:spPr>
+        <p:style>
+          <a:lnRef idx="1">
+            <a:schemeClr val="accent1"/>
+          </a:lnRef>
+          <a:fillRef idx="3">
+            <a:schemeClr val="accent1"/>
+          </a:fillRef>
+          <a:effectRef idx="2">
+            <a:schemeClr val="accent1"/>
+          </a:effectRef>
+          <a:fontRef idx="minor">
+            <a:schemeClr val="lt1"/>
+          </a:fontRef>
+        </p:style>
+        <p:txBody>
+          <a:bodyPr rtlCol="0" anchor="ctr"/>
+          <a:lstStyle/>
+          <a:p>
+            <a:pPr algn="ctr"/>
+          </a:p>
+        </p:txBody>
+      </p:sp>
+      <p:sp>
+        <p:nvSpPr>
+          <p:cNvPr id="17" name="TextBox 16"/>
+          <p:cNvSpPr txBox="1"/>
+          <p:nvPr/>
+        </p:nvSpPr>
+        <p:spPr>
+          <a:xfrm>
+            <a:off x="5696712" y="5660136"/>
+            <a:ext cx="5461711" cy="493776"/>
+          </a:xfrm>
+          <a:prstGeom prst="rect">
+            <a:avLst/>
+          </a:prstGeom>
+          <a:noFill/>
+        </p:spPr>
+        <p:txBody>
+          <a:bodyPr wrap="square">
+            <a:spAutoFit/>
+          </a:bodyPr>
+          <a:lstStyle/>
+          <a:p>
+            <a:r>
+              <a:rPr sz="960" b="1">
+                <a:solidFill>
+                  <a:srgbClr val="000000"/>
+                </a:solidFill>
+                <a:latin typeface="Segoe UI"/>
+                <a:hlinkClick r:id="rId2"/>
+              </a:rPr>
+              <a:t>▶ BUKA KODE LENGKAP DI GITHUB (slide_04_dart_vs_flutter.dart)</a:t>
+            </a:r>
+          </a:p>
+          <a:p>
+            <a:pPr>
+              <a:defRPr sz="760">
+                <a:solidFill>
+                  <a:srgbClr val="3C3C3C"/>
+                </a:solidFill>
+                <a:latin typeface="Segoe UI"/>
+              </a:defRPr>
+            </a:pPr>
+            <a:r>
+              <a:t>💡 Buka di browser / salin source code: github.com/antonprafanto/mobile2026</a:t>
             </a:r>
           </a:p>
         </p:txBody>
@@ -11847,7 +13461,7 @@
               </a:defRPr>
             </a:pPr>
             <a:r>
-              <a:t>arsitektur_grafis.dart  |  KODE / TERMINAL BERSIH</a:t>
+              <a:t>arsitektur_grafis.dart  |  KODE IMPLEMENTASI</a:t>
             </a:r>
           </a:p>
         </p:txBody>
@@ -11860,8 +13474,8 @@
         </p:nvSpPr>
         <p:spPr>
           <a:xfrm>
-            <a:off x="5669280" y="2176272"/>
-            <a:ext cx="5486400" cy="3977639"/>
+            <a:off x="5669280" y="2121408"/>
+            <a:ext cx="5486400" cy="3364992"/>
           </a:xfrm>
           <a:prstGeom prst="rect">
             <a:avLst/>
@@ -11875,7 +13489,7 @@
           <a:lstStyle/>
           <a:p>
             <a:pPr>
-              <a:defRPr sz="980">
+              <a:defRPr sz="919">
                 <a:solidFill>
                   <a:srgbClr val="F5F5F5"/>
                 </a:solidFill>
@@ -11909,6 +13523,142 @@
             <a:br/>
             <a:r>
               <a:t>// (Bebas jembatan, digambar langsung ke GPU layar!)</a:t>
+            </a:r>
+          </a:p>
+        </p:txBody>
+      </p:sp>
+      <p:sp>
+        <p:nvSpPr>
+          <p:cNvPr id="15" name="Rectangle 14"/>
+          <p:cNvSpPr/>
+          <p:nvPr/>
+        </p:nvSpPr>
+        <p:spPr>
+          <a:xfrm>
+            <a:off x="5660136" y="5669280"/>
+            <a:ext cx="5608015" cy="548640"/>
+          </a:xfrm>
+          <a:prstGeom prst="rect">
+            <a:avLst/>
+          </a:prstGeom>
+          <a:solidFill>
+            <a:srgbClr val="000000"/>
+          </a:solidFill>
+          <a:ln>
+            <a:noFill/>
+          </a:ln>
+        </p:spPr>
+        <p:style>
+          <a:lnRef idx="1">
+            <a:schemeClr val="accent1"/>
+          </a:lnRef>
+          <a:fillRef idx="3">
+            <a:schemeClr val="accent1"/>
+          </a:fillRef>
+          <a:effectRef idx="2">
+            <a:schemeClr val="accent1"/>
+          </a:effectRef>
+          <a:fontRef idx="minor">
+            <a:schemeClr val="lt1"/>
+          </a:fontRef>
+        </p:style>
+        <p:txBody>
+          <a:bodyPr rtlCol="0" anchor="ctr"/>
+          <a:lstStyle/>
+          <a:p>
+            <a:pPr algn="ctr"/>
+          </a:p>
+        </p:txBody>
+      </p:sp>
+      <p:sp>
+        <p:nvSpPr>
+          <p:cNvPr id="16" name="Rectangle 15"/>
+          <p:cNvSpPr/>
+          <p:nvPr/>
+        </p:nvSpPr>
+        <p:spPr>
+          <a:xfrm>
+            <a:off x="5623560" y="5632704"/>
+            <a:ext cx="5608015" cy="548640"/>
+          </a:xfrm>
+          <a:prstGeom prst="rect">
+            <a:avLst/>
+          </a:prstGeom>
+          <a:solidFill>
+            <a:srgbClr val="FFE600"/>
+          </a:solidFill>
+          <a:ln w="25400">
+            <a:solidFill>
+              <a:srgbClr val="000000"/>
+            </a:solidFill>
+          </a:ln>
+        </p:spPr>
+        <p:style>
+          <a:lnRef idx="1">
+            <a:schemeClr val="accent1"/>
+          </a:lnRef>
+          <a:fillRef idx="3">
+            <a:schemeClr val="accent1"/>
+          </a:fillRef>
+          <a:effectRef idx="2">
+            <a:schemeClr val="accent1"/>
+          </a:effectRef>
+          <a:fontRef idx="minor">
+            <a:schemeClr val="lt1"/>
+          </a:fontRef>
+        </p:style>
+        <p:txBody>
+          <a:bodyPr rtlCol="0" anchor="ctr"/>
+          <a:lstStyle/>
+          <a:p>
+            <a:pPr algn="ctr"/>
+          </a:p>
+        </p:txBody>
+      </p:sp>
+      <p:sp>
+        <p:nvSpPr>
+          <p:cNvPr id="17" name="TextBox 16"/>
+          <p:cNvSpPr txBox="1"/>
+          <p:nvPr/>
+        </p:nvSpPr>
+        <p:spPr>
+          <a:xfrm>
+            <a:off x="5696712" y="5660136"/>
+            <a:ext cx="5461711" cy="493776"/>
+          </a:xfrm>
+          <a:prstGeom prst="rect">
+            <a:avLst/>
+          </a:prstGeom>
+          <a:noFill/>
+        </p:spPr>
+        <p:txBody>
+          <a:bodyPr wrap="square">
+            <a:spAutoFit/>
+          </a:bodyPr>
+          <a:lstStyle/>
+          <a:p>
+            <a:r>
+              <a:rPr sz="960" b="1">
+                <a:solidFill>
+                  <a:srgbClr val="000000"/>
+                </a:solidFill>
+                <a:latin typeface="Segoe UI"/>
+                <a:hlinkClick r:id="rId2"/>
+              </a:rPr>
+              <a:t>▶ BUKA KODE LENGKAP DI GITHUB (slide_05_arsitektur_grafis.dart)</a:t>
+            </a:r>
+          </a:p>
+          <a:p>
+            <a:pPr>
+              <a:defRPr sz="760">
+                <a:solidFill>
+                  <a:srgbClr val="3C3C3C"/>
+                </a:solidFill>
+                <a:latin typeface="Segoe UI"/>
+              </a:defRPr>
+            </a:pPr>
+            <a:r>
+              <a:t>💡 Buka di browser / salin source code: github.com/antonprafanto/mobile2026</a:t>
             </a:r>
           </a:p>
         </p:txBody>
@@ -12502,7 +14252,7 @@
               </a:defRPr>
             </a:pPr>
             <a:r>
-              <a:t>impeller_status.sh  |  KODE / TERMINAL BERSIH</a:t>
+              <a:t>impeller_status.sh  |  KODE IMPLEMENTASI</a:t>
             </a:r>
           </a:p>
         </p:txBody>
@@ -12515,8 +14265,8 @@
         </p:nvSpPr>
         <p:spPr>
           <a:xfrm>
-            <a:off x="5669280" y="2176272"/>
-            <a:ext cx="5486400" cy="3977639"/>
+            <a:off x="5669280" y="2121408"/>
+            <a:ext cx="5486400" cy="3364992"/>
           </a:xfrm>
           <a:prstGeom prst="rect">
             <a:avLst/>
@@ -12530,7 +14280,7 @@
           <a:lstStyle/>
           <a:p>
             <a:pPr>
-              <a:defRPr sz="980">
+              <a:defRPr sz="919">
                 <a:solidFill>
                   <a:srgbClr val="F5F5F5"/>
                 </a:solidFill>
@@ -12565,6 +14315,142 @@
             <a:br/>
             <a:r>
               <a:t># setara dengan aplikasi native kelas atas!</a:t>
+            </a:r>
+          </a:p>
+        </p:txBody>
+      </p:sp>
+      <p:sp>
+        <p:nvSpPr>
+          <p:cNvPr id="15" name="Rectangle 14"/>
+          <p:cNvSpPr/>
+          <p:nvPr/>
+        </p:nvSpPr>
+        <p:spPr>
+          <a:xfrm>
+            <a:off x="5660136" y="5669280"/>
+            <a:ext cx="5608015" cy="548640"/>
+          </a:xfrm>
+          <a:prstGeom prst="rect">
+            <a:avLst/>
+          </a:prstGeom>
+          <a:solidFill>
+            <a:srgbClr val="000000"/>
+          </a:solidFill>
+          <a:ln>
+            <a:noFill/>
+          </a:ln>
+        </p:spPr>
+        <p:style>
+          <a:lnRef idx="1">
+            <a:schemeClr val="accent1"/>
+          </a:lnRef>
+          <a:fillRef idx="3">
+            <a:schemeClr val="accent1"/>
+          </a:fillRef>
+          <a:effectRef idx="2">
+            <a:schemeClr val="accent1"/>
+          </a:effectRef>
+          <a:fontRef idx="minor">
+            <a:schemeClr val="lt1"/>
+          </a:fontRef>
+        </p:style>
+        <p:txBody>
+          <a:bodyPr rtlCol="0" anchor="ctr"/>
+          <a:lstStyle/>
+          <a:p>
+            <a:pPr algn="ctr"/>
+          </a:p>
+        </p:txBody>
+      </p:sp>
+      <p:sp>
+        <p:nvSpPr>
+          <p:cNvPr id="16" name="Rectangle 15"/>
+          <p:cNvSpPr/>
+          <p:nvPr/>
+        </p:nvSpPr>
+        <p:spPr>
+          <a:xfrm>
+            <a:off x="5623560" y="5632704"/>
+            <a:ext cx="5608015" cy="548640"/>
+          </a:xfrm>
+          <a:prstGeom prst="rect">
+            <a:avLst/>
+          </a:prstGeom>
+          <a:solidFill>
+            <a:srgbClr val="FFE600"/>
+          </a:solidFill>
+          <a:ln w="25400">
+            <a:solidFill>
+              <a:srgbClr val="000000"/>
+            </a:solidFill>
+          </a:ln>
+        </p:spPr>
+        <p:style>
+          <a:lnRef idx="1">
+            <a:schemeClr val="accent1"/>
+          </a:lnRef>
+          <a:fillRef idx="3">
+            <a:schemeClr val="accent1"/>
+          </a:fillRef>
+          <a:effectRef idx="2">
+            <a:schemeClr val="accent1"/>
+          </a:effectRef>
+          <a:fontRef idx="minor">
+            <a:schemeClr val="lt1"/>
+          </a:fontRef>
+        </p:style>
+        <p:txBody>
+          <a:bodyPr rtlCol="0" anchor="ctr"/>
+          <a:lstStyle/>
+          <a:p>
+            <a:pPr algn="ctr"/>
+          </a:p>
+        </p:txBody>
+      </p:sp>
+      <p:sp>
+        <p:nvSpPr>
+          <p:cNvPr id="17" name="TextBox 16"/>
+          <p:cNvSpPr txBox="1"/>
+          <p:nvPr/>
+        </p:nvSpPr>
+        <p:spPr>
+          <a:xfrm>
+            <a:off x="5696712" y="5660136"/>
+            <a:ext cx="5461711" cy="493776"/>
+          </a:xfrm>
+          <a:prstGeom prst="rect">
+            <a:avLst/>
+          </a:prstGeom>
+          <a:noFill/>
+        </p:spPr>
+        <p:txBody>
+          <a:bodyPr wrap="square">
+            <a:spAutoFit/>
+          </a:bodyPr>
+          <a:lstStyle/>
+          <a:p>
+            <a:r>
+              <a:rPr sz="960" b="1">
+                <a:solidFill>
+                  <a:srgbClr val="000000"/>
+                </a:solidFill>
+                <a:latin typeface="Segoe UI"/>
+                <a:hlinkClick r:id="rId2"/>
+              </a:rPr>
+              <a:t>▶ BUKA KODE LENGKAP DI GITHUB (slide_06_impeller_engine_demo.dart)</a:t>
+            </a:r>
+          </a:p>
+          <a:p>
+            <a:pPr>
+              <a:defRPr sz="760">
+                <a:solidFill>
+                  <a:srgbClr val="3C3C3C"/>
+                </a:solidFill>
+                <a:latin typeface="Segoe UI"/>
+              </a:defRPr>
+            </a:pPr>
+            <a:r>
+              <a:t>💡 Buka di browser / salin source code: github.com/antonprafanto/mobile2026</a:t>
             </a:r>
           </a:p>
         </p:txBody>
@@ -13158,7 +15044,7 @@
               </a:defRPr>
             </a:pPr>
             <a:r>
-              <a:t>flutter_doctor.sh  |  KODE / TERMINAL BERSIH</a:t>
+              <a:t>flutter_doctor.sh  |  KODE IMPLEMENTASI</a:t>
             </a:r>
           </a:p>
         </p:txBody>
@@ -13171,8 +15057,8 @@
         </p:nvSpPr>
         <p:spPr>
           <a:xfrm>
-            <a:off x="5669280" y="2176272"/>
-            <a:ext cx="5486400" cy="3977639"/>
+            <a:off x="5669280" y="2121408"/>
+            <a:ext cx="5486400" cy="3364992"/>
           </a:xfrm>
           <a:prstGeom prst="rect">
             <a:avLst/>
@@ -13186,7 +15072,7 @@
           <a:lstStyle/>
           <a:p>
             <a:pPr>
-              <a:defRPr sz="980">
+              <a:defRPr sz="919">
                 <a:solidFill>
                   <a:srgbClr val="F5F5F5"/>
                 </a:solidFill>
@@ -13229,6 +15115,142 @@
             <a:br/>
             <a:r>
               <a:t># [✓] VS Code (version 1.9x)</a:t>
+            </a:r>
+          </a:p>
+        </p:txBody>
+      </p:sp>
+      <p:sp>
+        <p:nvSpPr>
+          <p:cNvPr id="15" name="Rectangle 14"/>
+          <p:cNvSpPr/>
+          <p:nvPr/>
+        </p:nvSpPr>
+        <p:spPr>
+          <a:xfrm>
+            <a:off x="5660136" y="5669280"/>
+            <a:ext cx="5608015" cy="548640"/>
+          </a:xfrm>
+          <a:prstGeom prst="rect">
+            <a:avLst/>
+          </a:prstGeom>
+          <a:solidFill>
+            <a:srgbClr val="000000"/>
+          </a:solidFill>
+          <a:ln>
+            <a:noFill/>
+          </a:ln>
+        </p:spPr>
+        <p:style>
+          <a:lnRef idx="1">
+            <a:schemeClr val="accent1"/>
+          </a:lnRef>
+          <a:fillRef idx="3">
+            <a:schemeClr val="accent1"/>
+          </a:fillRef>
+          <a:effectRef idx="2">
+            <a:schemeClr val="accent1"/>
+          </a:effectRef>
+          <a:fontRef idx="minor">
+            <a:schemeClr val="lt1"/>
+          </a:fontRef>
+        </p:style>
+        <p:txBody>
+          <a:bodyPr rtlCol="0" anchor="ctr"/>
+          <a:lstStyle/>
+          <a:p>
+            <a:pPr algn="ctr"/>
+          </a:p>
+        </p:txBody>
+      </p:sp>
+      <p:sp>
+        <p:nvSpPr>
+          <p:cNvPr id="16" name="Rectangle 15"/>
+          <p:cNvSpPr/>
+          <p:nvPr/>
+        </p:nvSpPr>
+        <p:spPr>
+          <a:xfrm>
+            <a:off x="5623560" y="5632704"/>
+            <a:ext cx="5608015" cy="548640"/>
+          </a:xfrm>
+          <a:prstGeom prst="rect">
+            <a:avLst/>
+          </a:prstGeom>
+          <a:solidFill>
+            <a:srgbClr val="FFE600"/>
+          </a:solidFill>
+          <a:ln w="25400">
+            <a:solidFill>
+              <a:srgbClr val="000000"/>
+            </a:solidFill>
+          </a:ln>
+        </p:spPr>
+        <p:style>
+          <a:lnRef idx="1">
+            <a:schemeClr val="accent1"/>
+          </a:lnRef>
+          <a:fillRef idx="3">
+            <a:schemeClr val="accent1"/>
+          </a:fillRef>
+          <a:effectRef idx="2">
+            <a:schemeClr val="accent1"/>
+          </a:effectRef>
+          <a:fontRef idx="minor">
+            <a:schemeClr val="lt1"/>
+          </a:fontRef>
+        </p:style>
+        <p:txBody>
+          <a:bodyPr rtlCol="0" anchor="ctr"/>
+          <a:lstStyle/>
+          <a:p>
+            <a:pPr algn="ctr"/>
+          </a:p>
+        </p:txBody>
+      </p:sp>
+      <p:sp>
+        <p:nvSpPr>
+          <p:cNvPr id="17" name="TextBox 16"/>
+          <p:cNvSpPr txBox="1"/>
+          <p:nvPr/>
+        </p:nvSpPr>
+        <p:spPr>
+          <a:xfrm>
+            <a:off x="5696712" y="5660136"/>
+            <a:ext cx="5461711" cy="493776"/>
+          </a:xfrm>
+          <a:prstGeom prst="rect">
+            <a:avLst/>
+          </a:prstGeom>
+          <a:noFill/>
+        </p:spPr>
+        <p:txBody>
+          <a:bodyPr wrap="square">
+            <a:spAutoFit/>
+          </a:bodyPr>
+          <a:lstStyle/>
+          <a:p>
+            <a:r>
+              <a:rPr sz="960" b="1">
+                <a:solidFill>
+                  <a:srgbClr val="000000"/>
+                </a:solidFill>
+                <a:latin typeface="Segoe UI"/>
+                <a:hlinkClick r:id="rId2"/>
+              </a:rPr>
+              <a:t>▶ BUKA KODE LENGKAP DI GITHUB (slide_07_diagnostik_flutter_doctor.dart)</a:t>
+            </a:r>
+          </a:p>
+          <a:p>
+            <a:pPr>
+              <a:defRPr sz="760">
+                <a:solidFill>
+                  <a:srgbClr val="3C3C3C"/>
+                </a:solidFill>
+                <a:latin typeface="Segoe UI"/>
+              </a:defRPr>
+            </a:pPr>
+            <a:r>
+              <a:t>💡 Buka di browser / salin source code: github.com/antonprafanto/mobile2026</a:t>
             </a:r>
           </a:p>
         </p:txBody>
@@ -13822,7 +15844,7 @@
               </a:defRPr>
             </a:pPr>
             <a:r>
-              <a:t>create_project.sh  |  KODE / TERMINAL BERSIH</a:t>
+              <a:t>create_project.sh  |  KODE IMPLEMENTASI</a:t>
             </a:r>
           </a:p>
         </p:txBody>
@@ -13835,8 +15857,8 @@
         </p:nvSpPr>
         <p:spPr>
           <a:xfrm>
-            <a:off x="5669280" y="2176272"/>
-            <a:ext cx="5486400" cy="3977639"/>
+            <a:off x="5669280" y="2121408"/>
+            <a:ext cx="5486400" cy="3364992"/>
           </a:xfrm>
           <a:prstGeom prst="rect">
             <a:avLst/>
@@ -13850,7 +15872,7 @@
           <a:lstStyle/>
           <a:p>
             <a:pPr>
-              <a:defRPr sz="980">
+              <a:defRPr sz="919">
                 <a:solidFill>
                   <a:srgbClr val="F5F5F5"/>
                 </a:solidFill>
@@ -13890,6 +15912,142 @@
             <a:br/>
             <a:r>
               <a:t>code .</a:t>
+            </a:r>
+          </a:p>
+        </p:txBody>
+      </p:sp>
+      <p:sp>
+        <p:nvSpPr>
+          <p:cNvPr id="15" name="Rectangle 14"/>
+          <p:cNvSpPr/>
+          <p:nvPr/>
+        </p:nvSpPr>
+        <p:spPr>
+          <a:xfrm>
+            <a:off x="5660136" y="5669280"/>
+            <a:ext cx="5608015" cy="548640"/>
+          </a:xfrm>
+          <a:prstGeom prst="rect">
+            <a:avLst/>
+          </a:prstGeom>
+          <a:solidFill>
+            <a:srgbClr val="000000"/>
+          </a:solidFill>
+          <a:ln>
+            <a:noFill/>
+          </a:ln>
+        </p:spPr>
+        <p:style>
+          <a:lnRef idx="1">
+            <a:schemeClr val="accent1"/>
+          </a:lnRef>
+          <a:fillRef idx="3">
+            <a:schemeClr val="accent1"/>
+          </a:fillRef>
+          <a:effectRef idx="2">
+            <a:schemeClr val="accent1"/>
+          </a:effectRef>
+          <a:fontRef idx="minor">
+            <a:schemeClr val="lt1"/>
+          </a:fontRef>
+        </p:style>
+        <p:txBody>
+          <a:bodyPr rtlCol="0" anchor="ctr"/>
+          <a:lstStyle/>
+          <a:p>
+            <a:pPr algn="ctr"/>
+          </a:p>
+        </p:txBody>
+      </p:sp>
+      <p:sp>
+        <p:nvSpPr>
+          <p:cNvPr id="16" name="Rectangle 15"/>
+          <p:cNvSpPr/>
+          <p:nvPr/>
+        </p:nvSpPr>
+        <p:spPr>
+          <a:xfrm>
+            <a:off x="5623560" y="5632704"/>
+            <a:ext cx="5608015" cy="548640"/>
+          </a:xfrm>
+          <a:prstGeom prst="rect">
+            <a:avLst/>
+          </a:prstGeom>
+          <a:solidFill>
+            <a:srgbClr val="FFE600"/>
+          </a:solidFill>
+          <a:ln w="25400">
+            <a:solidFill>
+              <a:srgbClr val="000000"/>
+            </a:solidFill>
+          </a:ln>
+        </p:spPr>
+        <p:style>
+          <a:lnRef idx="1">
+            <a:schemeClr val="accent1"/>
+          </a:lnRef>
+          <a:fillRef idx="3">
+            <a:schemeClr val="accent1"/>
+          </a:fillRef>
+          <a:effectRef idx="2">
+            <a:schemeClr val="accent1"/>
+          </a:effectRef>
+          <a:fontRef idx="minor">
+            <a:schemeClr val="lt1"/>
+          </a:fontRef>
+        </p:style>
+        <p:txBody>
+          <a:bodyPr rtlCol="0" anchor="ctr"/>
+          <a:lstStyle/>
+          <a:p>
+            <a:pPr algn="ctr"/>
+          </a:p>
+        </p:txBody>
+      </p:sp>
+      <p:sp>
+        <p:nvSpPr>
+          <p:cNvPr id="17" name="TextBox 16"/>
+          <p:cNvSpPr txBox="1"/>
+          <p:nvPr/>
+        </p:nvSpPr>
+        <p:spPr>
+          <a:xfrm>
+            <a:off x="5696712" y="5660136"/>
+            <a:ext cx="5461711" cy="493776"/>
+          </a:xfrm>
+          <a:prstGeom prst="rect">
+            <a:avLst/>
+          </a:prstGeom>
+          <a:noFill/>
+        </p:spPr>
+        <p:txBody>
+          <a:bodyPr wrap="square">
+            <a:spAutoFit/>
+          </a:bodyPr>
+          <a:lstStyle/>
+          <a:p>
+            <a:r>
+              <a:rPr sz="960" b="1">
+                <a:solidFill>
+                  <a:srgbClr val="000000"/>
+                </a:solidFill>
+                <a:latin typeface="Segoe UI"/>
+                <a:hlinkClick r:id="rId2"/>
+              </a:rPr>
+              <a:t>▶ BUKA KODE LENGKAP DI GITHUB (slide_08_aturan_penamaan_proyek.dart)</a:t>
+            </a:r>
+          </a:p>
+          <a:p>
+            <a:pPr>
+              <a:defRPr sz="760">
+                <a:solidFill>
+                  <a:srgbClr val="3C3C3C"/>
+                </a:solidFill>
+                <a:latin typeface="Segoe UI"/>
+              </a:defRPr>
+            </a:pPr>
+            <a:r>
+              <a:t>💡 Buka di browser / salin source code: github.com/antonprafanto/mobile2026</a:t>
             </a:r>
           </a:p>
         </p:txBody>
@@ -14483,7 +16641,7 @@
               </a:defRPr>
             </a:pPr>
             <a:r>
-              <a:t>struktur_folder.txt  |  KODE / TERMINAL BERSIH</a:t>
+              <a:t>struktur_folder.txt  |  KODE IMPLEMENTASI</a:t>
             </a:r>
           </a:p>
         </p:txBody>
@@ -14496,8 +16654,8 @@
         </p:nvSpPr>
         <p:spPr>
           <a:xfrm>
-            <a:off x="5669280" y="2176272"/>
-            <a:ext cx="5486400" cy="3977639"/>
+            <a:off x="5669280" y="2121408"/>
+            <a:ext cx="5486400" cy="3364992"/>
           </a:xfrm>
           <a:prstGeom prst="rect">
             <a:avLst/>
@@ -14511,7 +16669,7 @@
           <a:lstStyle/>
           <a:p>
             <a:pPr>
-              <a:defRPr sz="980">
+              <a:defRPr sz="919">
                 <a:solidFill>
                   <a:srgbClr val="F5F5F5"/>
                 </a:solidFill>
@@ -14548,6 +16706,142 @@
             <a:br/>
             <a:r>
               <a:t>└── pubspec.yaml      &lt;- 📜 KTP &amp; Daftar paket pustaka/gambar</a:t>
+            </a:r>
+          </a:p>
+        </p:txBody>
+      </p:sp>
+      <p:sp>
+        <p:nvSpPr>
+          <p:cNvPr id="15" name="Rectangle 14"/>
+          <p:cNvSpPr/>
+          <p:nvPr/>
+        </p:nvSpPr>
+        <p:spPr>
+          <a:xfrm>
+            <a:off x="5660136" y="5669280"/>
+            <a:ext cx="5608015" cy="548640"/>
+          </a:xfrm>
+          <a:prstGeom prst="rect">
+            <a:avLst/>
+          </a:prstGeom>
+          <a:solidFill>
+            <a:srgbClr val="000000"/>
+          </a:solidFill>
+          <a:ln>
+            <a:noFill/>
+          </a:ln>
+        </p:spPr>
+        <p:style>
+          <a:lnRef idx="1">
+            <a:schemeClr val="accent1"/>
+          </a:lnRef>
+          <a:fillRef idx="3">
+            <a:schemeClr val="accent1"/>
+          </a:fillRef>
+          <a:effectRef idx="2">
+            <a:schemeClr val="accent1"/>
+          </a:effectRef>
+          <a:fontRef idx="minor">
+            <a:schemeClr val="lt1"/>
+          </a:fontRef>
+        </p:style>
+        <p:txBody>
+          <a:bodyPr rtlCol="0" anchor="ctr"/>
+          <a:lstStyle/>
+          <a:p>
+            <a:pPr algn="ctr"/>
+          </a:p>
+        </p:txBody>
+      </p:sp>
+      <p:sp>
+        <p:nvSpPr>
+          <p:cNvPr id="16" name="Rectangle 15"/>
+          <p:cNvSpPr/>
+          <p:nvPr/>
+        </p:nvSpPr>
+        <p:spPr>
+          <a:xfrm>
+            <a:off x="5623560" y="5632704"/>
+            <a:ext cx="5608015" cy="548640"/>
+          </a:xfrm>
+          <a:prstGeom prst="rect">
+            <a:avLst/>
+          </a:prstGeom>
+          <a:solidFill>
+            <a:srgbClr val="FFE600"/>
+          </a:solidFill>
+          <a:ln w="25400">
+            <a:solidFill>
+              <a:srgbClr val="000000"/>
+            </a:solidFill>
+          </a:ln>
+        </p:spPr>
+        <p:style>
+          <a:lnRef idx="1">
+            <a:schemeClr val="accent1"/>
+          </a:lnRef>
+          <a:fillRef idx="3">
+            <a:schemeClr val="accent1"/>
+          </a:fillRef>
+          <a:effectRef idx="2">
+            <a:schemeClr val="accent1"/>
+          </a:effectRef>
+          <a:fontRef idx="minor">
+            <a:schemeClr val="lt1"/>
+          </a:fontRef>
+        </p:style>
+        <p:txBody>
+          <a:bodyPr rtlCol="0" anchor="ctr"/>
+          <a:lstStyle/>
+          <a:p>
+            <a:pPr algn="ctr"/>
+          </a:p>
+        </p:txBody>
+      </p:sp>
+      <p:sp>
+        <p:nvSpPr>
+          <p:cNvPr id="17" name="TextBox 16"/>
+          <p:cNvSpPr txBox="1"/>
+          <p:nvPr/>
+        </p:nvSpPr>
+        <p:spPr>
+          <a:xfrm>
+            <a:off x="5696712" y="5660136"/>
+            <a:ext cx="5461711" cy="493776"/>
+          </a:xfrm>
+          <a:prstGeom prst="rect">
+            <a:avLst/>
+          </a:prstGeom>
+          <a:noFill/>
+        </p:spPr>
+        <p:txBody>
+          <a:bodyPr wrap="square">
+            <a:spAutoFit/>
+          </a:bodyPr>
+          <a:lstStyle/>
+          <a:p>
+            <a:r>
+              <a:rPr sz="960" b="1">
+                <a:solidFill>
+                  <a:srgbClr val="000000"/>
+                </a:solidFill>
+                <a:latin typeface="Segoe UI"/>
+                <a:hlinkClick r:id="rId2"/>
+              </a:rPr>
+              <a:t>▶ BUKA KODE LENGKAP DI GITHUB (slide_09_struktur_folder_proyek.dart)</a:t>
+            </a:r>
+          </a:p>
+          <a:p>
+            <a:pPr>
+              <a:defRPr sz="760">
+                <a:solidFill>
+                  <a:srgbClr val="3C3C3C"/>
+                </a:solidFill>
+                <a:latin typeface="Segoe UI"/>
+              </a:defRPr>
+            </a:pPr>
+            <a:r>
+              <a:t>💡 Buka di browser / salin source code: github.com/antonprafanto/mobile2026</a:t>
             </a:r>
           </a:p>
         </p:txBody>

</xml_diff>

<commit_message>
docs & refactor: lengkapi README panduan mandiri P1-P6 dan standarisasi narasi akademis formal di seluruh slide PPTX
</commit_message>
<xml_diff>
--- a/03_slide_presentasi/PERTEMUAN_01_Pengantar_Flutter_dan_Ekosistem.pptx
+++ b/03_slide_presentasi/PERTEMUAN_01_Pengantar_Flutter_dan_Ekosistem.pptx
@@ -3699,7 +3699,7 @@
               </a:defRPr>
             </a:pPr>
             <a:r>
-              <a:t>■  Jebakan Klasik Pemula: Format YAML SANGAT SENSITIF terhadap spasi!</a:t>
+              <a:t>■  Catatan Kritis: Format YAML SANGAT SENSITIF terhadap indentasi spasi!</a:t>
             </a:r>
           </a:p>
           <a:p>
@@ -4537,7 +4537,7 @@
               </a:defRPr>
             </a:pPr>
             <a:r>
-              <a:t>💡 Tips Praktik: Hot Reload adalah fitur terbaik Flutter yang membuat ngoding terasa seperti mengedit dokumen live!</a:t>
+              <a:t>💡 Tips Praktik: Hot Reload adalah fitur terbaik Flutter yang membuat siklus pengembangan antarmuka berjalan sangat cepat!</a:t>
             </a:r>
           </a:p>
         </p:txBody>
@@ -8595,7 +8595,7 @@
               </a:defRPr>
             </a:pPr>
             <a:r>
-              <a:t>■  Shortcut Sakti: 'Ctrl + `' untuk buka terminal, 'Ctrl + P' untuk cari berkas kilat, dan 'Alt + Enter' untuk bantuan refactor kode otomatis.</a:t>
+              <a:t>■  Pintasan Produktivitas: 'Ctrl + `' untuk buka terminal, 'Ctrl + P' untuk cari berkas kilat, dan 'Alt + Enter' untuk bantuan refactor kode otomatis.</a:t>
             </a:r>
           </a:p>
           <a:p>
@@ -16268,7 +16268,7 @@
               </a:defRPr>
             </a:pPr>
             <a:r>
-              <a:t>Jangan Pusing! Pahami 3 Folder Utama Ini</a:t>
+              <a:t>Struktur Folder Proyek: 3 Direktori Utama</a:t>
             </a:r>
           </a:p>
         </p:txBody>
@@ -16427,7 +16427,7 @@
               </a:defRPr>
             </a:pPr>
             <a:r>
-              <a:t>■  1. folder 'lib/' (RUMAH UTAMA): 99% waktu ngoding Anda ada di sini. Berkas pintu gerbang utama adalah 'lib/main.dart'.</a:t>
+              <a:t>■  1. folder 'lib/' (RUMAH UTAMA): pusat seluruh kode logika dan tampilan aplikasi. Berkas gerbang utama adalah 'lib/main.dart'.</a:t>
             </a:r>
           </a:p>
           <a:p>
@@ -16693,7 +16693,7 @@
             </a:r>
             <a:br/>
             <a:r>
-              <a:t>├── lib/              &lt;- 🌟 TEMPAT KITA NGODING SEHARI-HARI!</a:t>
+              <a:t>├── lib/              &lt;- 🌟 PUSAT PENULISAN KODE SUMBER UTAMA APLIKASI!</a:t>
             </a:r>
             <a:br/>
             <a:r>

</xml_diff>

<commit_message>
style(presentation): standardisasi tipografi dan ukuran font seluruh slide P1-P3 dan P5-P7 sesuai standar emas PPT 4
</commit_message>
<xml_diff>
--- a/03_slide_presentasi/PERTEMUAN_01_Pengantar_Flutter_dan_Ekosistem.pptx
+++ b/03_slide_presentasi/PERTEMUAN_01_Pengantar_Flutter_dan_Ekosistem.pptx
@@ -3278,7 +3278,7 @@
               <a:spcAft>
                 <a:spcPts val="1400"/>
               </a:spcAft>
-              <a:defRPr sz="3100" b="1">
+              <a:defRPr sz="3000" b="1">
                 <a:solidFill>
                   <a:srgbClr val="000000"/>
                 </a:solidFill>
@@ -3296,7 +3296,7 @@
           <a:p>
             <a:pPr>
               <a:spcAft>
-                <a:spcPts val="4000"/>
+                <a:spcPts val="3800"/>
               </a:spcAft>
               <a:defRPr sz="1500">
                 <a:solidFill>
@@ -3319,7 +3319,7 @@
               </a:defRPr>
             </a:pPr>
             <a:r>
-              <a:t>■  Program Studi Teknik Informatika  ■  OUTCOME-BASED EDUCATION (OBE)</a:t>
+              <a:t>■  Program Studi Teknik Informatika  ■  OUTCOME-BASED EDUCATION (OBE) • SUB-CPMK 1</a:t>
             </a:r>
           </a:p>
         </p:txBody>
@@ -3667,15 +3667,15 @@
               </a:defRPr>
             </a:pPr>
             <a:r>
-              <a:t>KONSEP &amp; CARA KERJA</a:t>
+              <a:t>KONSEP &amp; ALUR KERJA</a:t>
             </a:r>
           </a:p>
           <a:p>
             <a:pPr>
               <a:spcAft>
-                <a:spcPts val="600"/>
+                <a:spcPts val="500"/>
               </a:spcAft>
-              <a:defRPr sz="1100">
+              <a:defRPr sz="1060">
                 <a:solidFill>
                   <a:srgbClr val="141414"/>
                 </a:solidFill>
@@ -3689,9 +3689,9 @@
           <a:p>
             <a:pPr>
               <a:spcAft>
-                <a:spcPts val="600"/>
+                <a:spcPts val="500"/>
               </a:spcAft>
-              <a:defRPr sz="1100">
+              <a:defRPr sz="1060">
                 <a:solidFill>
                   <a:srgbClr val="141414"/>
                 </a:solidFill>
@@ -3705,9 +3705,9 @@
           <a:p>
             <a:pPr>
               <a:spcAft>
-                <a:spcPts val="600"/>
+                <a:spcPts val="500"/>
               </a:spcAft>
-              <a:defRPr sz="1100">
+              <a:defRPr sz="1060">
                 <a:solidFill>
                   <a:srgbClr val="141414"/>
                 </a:solidFill>
@@ -3720,7 +3720,7 @@
           </a:p>
           <a:p>
             <a:pPr>
-              <a:defRPr sz="1050" b="1">
+              <a:defRPr sz="1019" b="1">
                 <a:solidFill>
                   <a:srgbClr val="000000"/>
                 </a:solidFill>
@@ -3728,7 +3728,7 @@
               </a:defRPr>
             </a:pPr>
             <a:r>
-              <a:t>💡 Tips Praktik: Jika pubspec error merah, periksa apakah Anda tidak sengaja menekan tombol Tab!</a:t>
+              <a:t>💡 Tips Praktis: Jika pubspec error merah, periksa apakah Anda tidak sengaja menekan tombol Tab!</a:t>
             </a:r>
           </a:p>
         </p:txBody>
@@ -3836,7 +3836,7 @@
             <a:avLst/>
           </a:prstGeom>
           <a:solidFill>
-            <a:srgbClr val="FFE600"/>
+            <a:srgbClr val="FB7185"/>
           </a:solidFill>
           <a:ln w="31750">
             <a:solidFill>
@@ -3925,7 +3925,7 @@
           <a:lstStyle/>
           <a:p>
             <a:pPr>
-              <a:defRPr sz="919">
+              <a:defRPr sz="910">
                 <a:solidFill>
                   <a:srgbClr val="F5F5F5"/>
                 </a:solidFill>
@@ -4476,15 +4476,15 @@
               </a:defRPr>
             </a:pPr>
             <a:r>
-              <a:t>KONSEP &amp; CARA KERJA</a:t>
+              <a:t>KONSEP &amp; ALUR KERJA</a:t>
             </a:r>
           </a:p>
           <a:p>
             <a:pPr>
               <a:spcAft>
-                <a:spcPts val="600"/>
+                <a:spcPts val="500"/>
               </a:spcAft>
-              <a:defRPr sz="1100">
+              <a:defRPr sz="1060">
                 <a:solidFill>
                   <a:srgbClr val="141414"/>
                 </a:solidFill>
@@ -4498,9 +4498,9 @@
           <a:p>
             <a:pPr>
               <a:spcAft>
-                <a:spcPts val="600"/>
+                <a:spcPts val="500"/>
               </a:spcAft>
-              <a:defRPr sz="1100">
+              <a:defRPr sz="1060">
                 <a:solidFill>
                   <a:srgbClr val="141414"/>
                 </a:solidFill>
@@ -4514,9 +4514,9 @@
           <a:p>
             <a:pPr>
               <a:spcAft>
-                <a:spcPts val="600"/>
+                <a:spcPts val="500"/>
               </a:spcAft>
-              <a:defRPr sz="1100">
+              <a:defRPr sz="1060">
                 <a:solidFill>
                   <a:srgbClr val="141414"/>
                 </a:solidFill>
@@ -4529,7 +4529,7 @@
           </a:p>
           <a:p>
             <a:pPr>
-              <a:defRPr sz="1050" b="1">
+              <a:defRPr sz="1019" b="1">
                 <a:solidFill>
                   <a:srgbClr val="000000"/>
                 </a:solidFill>
@@ -4537,7 +4537,7 @@
               </a:defRPr>
             </a:pPr>
             <a:r>
-              <a:t>💡 Tips Praktik: Hot Reload adalah fitur terbaik Flutter yang membuat siklus pengembangan antarmuka berjalan sangat cepat!</a:t>
+              <a:t>💡 Tips Praktis: Hot Reload adalah fitur terbaik Flutter yang membuat siklus pengembangan antarmuka berjalan sangat cepat!</a:t>
             </a:r>
           </a:p>
         </p:txBody>
@@ -4645,7 +4645,7 @@
             <a:avLst/>
           </a:prstGeom>
           <a:solidFill>
-            <a:srgbClr val="FFE600"/>
+            <a:srgbClr val="4ADE80"/>
           </a:solidFill>
           <a:ln w="31750">
             <a:solidFill>
@@ -4734,7 +4734,7 @@
           <a:lstStyle/>
           <a:p>
             <a:pPr>
-              <a:defRPr sz="919">
+              <a:defRPr sz="910">
                 <a:solidFill>
                   <a:srgbClr val="F5F5F5"/>
                 </a:solidFill>
@@ -5267,15 +5267,15 @@
               </a:defRPr>
             </a:pPr>
             <a:r>
-              <a:t>KONSEP &amp; CARA KERJA</a:t>
+              <a:t>KONSEP &amp; ALUR KERJA</a:t>
             </a:r>
           </a:p>
           <a:p>
             <a:pPr>
               <a:spcAft>
-                <a:spcPts val="600"/>
+                <a:spcPts val="500"/>
               </a:spcAft>
-              <a:defRPr sz="1100">
+              <a:defRPr sz="1060">
                 <a:solidFill>
                   <a:srgbClr val="141414"/>
                 </a:solidFill>
@@ -5289,9 +5289,9 @@
           <a:p>
             <a:pPr>
               <a:spcAft>
-                <a:spcPts val="600"/>
+                <a:spcPts val="500"/>
               </a:spcAft>
-              <a:defRPr sz="1100">
+              <a:defRPr sz="1060">
                 <a:solidFill>
                   <a:srgbClr val="141414"/>
                 </a:solidFill>
@@ -5305,9 +5305,9 @@
           <a:p>
             <a:pPr>
               <a:spcAft>
-                <a:spcPts val="600"/>
+                <a:spcPts val="500"/>
               </a:spcAft>
-              <a:defRPr sz="1100">
+              <a:defRPr sz="1060">
                 <a:solidFill>
                   <a:srgbClr val="141414"/>
                 </a:solidFill>
@@ -5321,9 +5321,9 @@
           <a:p>
             <a:pPr>
               <a:spcAft>
-                <a:spcPts val="600"/>
+                <a:spcPts val="500"/>
               </a:spcAft>
-              <a:defRPr sz="1100">
+              <a:defRPr sz="1060">
                 <a:solidFill>
                   <a:srgbClr val="141414"/>
                 </a:solidFill>
@@ -5337,9 +5337,9 @@
           <a:p>
             <a:pPr>
               <a:spcAft>
-                <a:spcPts val="600"/>
+                <a:spcPts val="500"/>
               </a:spcAft>
-              <a:defRPr sz="1100">
+              <a:defRPr sz="1060">
                 <a:solidFill>
                   <a:srgbClr val="141414"/>
                 </a:solidFill>
@@ -5352,7 +5352,7 @@
           </a:p>
           <a:p>
             <a:pPr>
-              <a:defRPr sz="1050" b="1">
+              <a:defRPr sz="1019" b="1">
                 <a:solidFill>
                   <a:srgbClr val="000000"/>
                 </a:solidFill>
@@ -5360,7 +5360,7 @@
               </a:defRPr>
             </a:pPr>
             <a:r>
-              <a:t>💡 Tips Praktik: Setiap tampilan di Flutter tersusun dari widget yang saling membungkus!</a:t>
+              <a:t>💡 Tips Praktis: Setiap tampilan di Flutter tersusun dari widget yang saling membungkus!</a:t>
             </a:r>
           </a:p>
         </p:txBody>
@@ -5557,7 +5557,7 @@
           <a:lstStyle/>
           <a:p>
             <a:pPr>
-              <a:defRPr sz="919">
+              <a:defRPr sz="910">
                 <a:solidFill>
                   <a:srgbClr val="F5F5F5"/>
                 </a:solidFill>
@@ -6136,15 +6136,15 @@
               </a:defRPr>
             </a:pPr>
             <a:r>
-              <a:t>KONSEP &amp; CARA KERJA</a:t>
+              <a:t>KONSEP &amp; ALUR KERJA</a:t>
             </a:r>
           </a:p>
           <a:p>
             <a:pPr>
               <a:spcAft>
-                <a:spcPts val="600"/>
+                <a:spcPts val="500"/>
               </a:spcAft>
-              <a:defRPr sz="1100">
+              <a:defRPr sz="1060">
                 <a:solidFill>
                   <a:srgbClr val="141414"/>
                 </a:solidFill>
@@ -6158,9 +6158,9 @@
           <a:p>
             <a:pPr>
               <a:spcAft>
-                <a:spcPts val="600"/>
+                <a:spcPts val="500"/>
               </a:spcAft>
-              <a:defRPr sz="1100">
+              <a:defRPr sz="1060">
                 <a:solidFill>
                   <a:srgbClr val="141414"/>
                 </a:solidFill>
@@ -6174,9 +6174,9 @@
           <a:p>
             <a:pPr>
               <a:spcAft>
-                <a:spcPts val="600"/>
+                <a:spcPts val="500"/>
               </a:spcAft>
-              <a:defRPr sz="1100">
+              <a:defRPr sz="1060">
                 <a:solidFill>
                   <a:srgbClr val="141414"/>
                 </a:solidFill>
@@ -6190,9 +6190,9 @@
           <a:p>
             <a:pPr>
               <a:spcAft>
-                <a:spcPts val="600"/>
+                <a:spcPts val="500"/>
               </a:spcAft>
-              <a:defRPr sz="1100">
+              <a:defRPr sz="1060">
                 <a:solidFill>
                   <a:srgbClr val="141414"/>
                 </a:solidFill>
@@ -6205,7 +6205,7 @@
           </a:p>
           <a:p>
             <a:pPr>
-              <a:defRPr sz="1050" b="1">
+              <a:defRPr sz="1019" b="1">
                 <a:solidFill>
                   <a:srgbClr val="000000"/>
                 </a:solidFill>
@@ -6213,7 +6213,7 @@
               </a:defRPr>
             </a:pPr>
             <a:r>
-              <a:t>💡 Tips Praktik: Fungsi setState() adalah fondasi paling awal dari aplikasi yang interaktif dan dinamis!</a:t>
+              <a:t>💡 Tips Praktis: Fungsi setState() adalah fondasi paling awal dari aplikasi yang interaktif dan dinamis!</a:t>
             </a:r>
           </a:p>
         </p:txBody>
@@ -6321,7 +6321,7 @@
             <a:avLst/>
           </a:prstGeom>
           <a:solidFill>
-            <a:srgbClr val="FFE600"/>
+            <a:srgbClr val="38BDF8"/>
           </a:solidFill>
           <a:ln w="31750">
             <a:solidFill>
@@ -6410,7 +6410,7 @@
           <a:lstStyle/>
           <a:p>
             <a:pPr>
-              <a:defRPr sz="919">
+              <a:defRPr sz="910">
                 <a:solidFill>
                   <a:srgbClr val="F5F5F5"/>
                 </a:solidFill>
@@ -6969,15 +6969,15 @@
               </a:defRPr>
             </a:pPr>
             <a:r>
-              <a:t>KONSEP &amp; CARA KERJA</a:t>
+              <a:t>KONSEP &amp; ALUR KERJA</a:t>
             </a:r>
           </a:p>
           <a:p>
             <a:pPr>
               <a:spcAft>
-                <a:spcPts val="600"/>
+                <a:spcPts val="500"/>
               </a:spcAft>
-              <a:defRPr sz="1100">
+              <a:defRPr sz="1060">
                 <a:solidFill>
                   <a:srgbClr val="141414"/>
                 </a:solidFill>
@@ -6991,9 +6991,9 @@
           <a:p>
             <a:pPr>
               <a:spcAft>
-                <a:spcPts val="600"/>
+                <a:spcPts val="500"/>
               </a:spcAft>
-              <a:defRPr sz="1100">
+              <a:defRPr sz="1060">
                 <a:solidFill>
                   <a:srgbClr val="141414"/>
                 </a:solidFill>
@@ -7007,9 +7007,9 @@
           <a:p>
             <a:pPr>
               <a:spcAft>
-                <a:spcPts val="600"/>
+                <a:spcPts val="500"/>
               </a:spcAft>
-              <a:defRPr sz="1100">
+              <a:defRPr sz="1060">
                 <a:solidFill>
                   <a:srgbClr val="141414"/>
                 </a:solidFill>
@@ -7022,7 +7022,7 @@
           </a:p>
           <a:p>
             <a:pPr>
-              <a:defRPr sz="1050" b="1">
+              <a:defRPr sz="1019" b="1">
                 <a:solidFill>
                   <a:srgbClr val="000000"/>
                 </a:solidFill>
@@ -7030,7 +7030,7 @@
               </a:defRPr>
             </a:pPr>
             <a:r>
-              <a:t>💡 Tips Praktik: Gunakan Chrome untuk belajar tata letak UI agar laptop Anda tetap dingin dan baterai awet!</a:t>
+              <a:t>💡 Tips Praktis: Gunakan Chrome untuk belajar tata letak UI agar laptop Anda tetap dingin dan baterai awet!</a:t>
             </a:r>
           </a:p>
         </p:txBody>
@@ -7138,7 +7138,7 @@
             <a:avLst/>
           </a:prstGeom>
           <a:solidFill>
-            <a:srgbClr val="FFE600"/>
+            <a:srgbClr val="C084FC"/>
           </a:solidFill>
           <a:ln w="31750">
             <a:solidFill>
@@ -7227,7 +7227,7 @@
           <a:lstStyle/>
           <a:p>
             <a:pPr>
-              <a:defRPr sz="919">
+              <a:defRPr sz="910">
                 <a:solidFill>
                   <a:srgbClr val="F5F5F5"/>
                 </a:solidFill>
@@ -7750,15 +7750,15 @@
               </a:defRPr>
             </a:pPr>
             <a:r>
-              <a:t>KONSEP &amp; CARA KERJA</a:t>
+              <a:t>KONSEP &amp; ALUR KERJA</a:t>
             </a:r>
           </a:p>
           <a:p>
             <a:pPr>
               <a:spcAft>
-                <a:spcPts val="600"/>
+                <a:spcPts val="500"/>
               </a:spcAft>
-              <a:defRPr sz="1100">
+              <a:defRPr sz="1060">
                 <a:solidFill>
                   <a:srgbClr val="141414"/>
                 </a:solidFill>
@@ -7772,9 +7772,9 @@
           <a:p>
             <a:pPr>
               <a:spcAft>
-                <a:spcPts val="600"/>
+                <a:spcPts val="500"/>
               </a:spcAft>
-              <a:defRPr sz="1100">
+              <a:defRPr sz="1060">
                 <a:solidFill>
                   <a:srgbClr val="141414"/>
                 </a:solidFill>
@@ -7788,9 +7788,9 @@
           <a:p>
             <a:pPr>
               <a:spcAft>
-                <a:spcPts val="600"/>
+                <a:spcPts val="500"/>
               </a:spcAft>
-              <a:defRPr sz="1100">
+              <a:defRPr sz="1060">
                 <a:solidFill>
                   <a:srgbClr val="141414"/>
                 </a:solidFill>
@@ -7804,9 +7804,9 @@
           <a:p>
             <a:pPr>
               <a:spcAft>
-                <a:spcPts val="600"/>
+                <a:spcPts val="500"/>
               </a:spcAft>
-              <a:defRPr sz="1100">
+              <a:defRPr sz="1060">
                 <a:solidFill>
                   <a:srgbClr val="141414"/>
                 </a:solidFill>
@@ -7819,7 +7819,7 @@
           </a:p>
           <a:p>
             <a:pPr>
-              <a:defRPr sz="1050" b="1">
+              <a:defRPr sz="1019" b="1">
                 <a:solidFill>
                   <a:srgbClr val="000000"/>
                 </a:solidFill>
@@ -7827,7 +7827,7 @@
               </a:defRPr>
             </a:pPr>
             <a:r>
-              <a:t>💡 Tips Praktik: Pastikan kabel USB adalah kabel data, bukan hanya kabel charger pengisi daya saja!</a:t>
+              <a:t>💡 Tips Praktis: Pastikan kabel USB adalah kabel data, bukan hanya kabel charger pengisi daya saja!</a:t>
             </a:r>
           </a:p>
         </p:txBody>
@@ -7935,7 +7935,7 @@
             <a:avLst/>
           </a:prstGeom>
           <a:solidFill>
-            <a:srgbClr val="FFE600"/>
+            <a:srgbClr val="FB7185"/>
           </a:solidFill>
           <a:ln w="31750">
             <a:solidFill>
@@ -8024,7 +8024,7 @@
           <a:lstStyle/>
           <a:p>
             <a:pPr>
-              <a:defRPr sz="919">
+              <a:defRPr sz="910">
                 <a:solidFill>
                   <a:srgbClr val="F5F5F5"/>
                 </a:solidFill>
@@ -8547,15 +8547,15 @@
               </a:defRPr>
             </a:pPr>
             <a:r>
-              <a:t>KONSEP &amp; CARA KERJA</a:t>
+              <a:t>KONSEP &amp; ALUR KERJA</a:t>
             </a:r>
           </a:p>
           <a:p>
             <a:pPr>
               <a:spcAft>
-                <a:spcPts val="600"/>
+                <a:spcPts val="500"/>
               </a:spcAft>
-              <a:defRPr sz="1100">
+              <a:defRPr sz="1060">
                 <a:solidFill>
                   <a:srgbClr val="141414"/>
                 </a:solidFill>
@@ -8569,9 +8569,9 @@
           <a:p>
             <a:pPr>
               <a:spcAft>
-                <a:spcPts val="600"/>
+                <a:spcPts val="500"/>
               </a:spcAft>
-              <a:defRPr sz="1100">
+              <a:defRPr sz="1060">
                 <a:solidFill>
                   <a:srgbClr val="141414"/>
                 </a:solidFill>
@@ -8585,9 +8585,9 @@
           <a:p>
             <a:pPr>
               <a:spcAft>
-                <a:spcPts val="600"/>
+                <a:spcPts val="500"/>
               </a:spcAft>
-              <a:defRPr sz="1100">
+              <a:defRPr sz="1060">
                 <a:solidFill>
                   <a:srgbClr val="141414"/>
                 </a:solidFill>
@@ -8600,7 +8600,7 @@
           </a:p>
           <a:p>
             <a:pPr>
-              <a:defRPr sz="1050" b="1">
+              <a:defRPr sz="1019" b="1">
                 <a:solidFill>
                   <a:srgbClr val="000000"/>
                 </a:solidFill>
@@ -8608,7 +8608,7 @@
               </a:defRPr>
             </a:pPr>
             <a:r>
-              <a:t>💡 Tips Praktik: Aktifkan formatOnSave agar kode Anda langsung rapi setiap kali menekan Ctrl + S!</a:t>
+              <a:t>💡 Tips Praktis: Aktifkan formatOnSave agar kode Anda langsung rapi setiap kali menekan Ctrl + S!</a:t>
             </a:r>
           </a:p>
         </p:txBody>
@@ -8716,7 +8716,7 @@
             <a:avLst/>
           </a:prstGeom>
           <a:solidFill>
-            <a:srgbClr val="FFE600"/>
+            <a:srgbClr val="4ADE80"/>
           </a:solidFill>
           <a:ln w="31750">
             <a:solidFill>
@@ -8805,7 +8805,7 @@
           <a:lstStyle/>
           <a:p>
             <a:pPr>
-              <a:defRPr sz="919">
+              <a:defRPr sz="910">
                 <a:solidFill>
                   <a:srgbClr val="F5F5F5"/>
                 </a:solidFill>
@@ -9387,7 +9387,7 @@
               </a:defRPr>
             </a:pPr>
             <a:r>
-              <a:t>⏱️ ALOKASI: 45 MENIT  ■  TARGET UJI: SMARTPHONE FISIK VIA USB / BROWSER CHROME</a:t>
+              <a:t>⏱️ ALOKASI: 45 MENIT  ■  TARGET UJI: BROWSER CHROME ATAU SMARTPHONE FISIK</a:t>
             </a:r>
           </a:p>
         </p:txBody>
@@ -9400,7 +9400,7 @@
         </p:nvSpPr>
         <p:spPr>
           <a:xfrm>
-            <a:off x="1188720" y="2212848"/>
+            <a:off x="1188720" y="2194560"/>
             <a:ext cx="9784080" cy="3291840"/>
           </a:xfrm>
           <a:prstGeom prst="rect">
@@ -9416,25 +9416,41 @@
           <a:p>
             <a:pPr>
               <a:spcAft>
+                <a:spcPts val="600"/>
+              </a:spcAft>
+              <a:defRPr sz="1200" b="1">
+                <a:solidFill>
+                  <a:srgbClr val="000000"/>
+                </a:solidFill>
+                <a:latin typeface="Segoe UI"/>
+              </a:defRPr>
+            </a:pPr>
+            <a:r>
+              <a:t>LANGKAH KERJA &amp; SPESIFIKASI TUGAS:</a:t>
+            </a:r>
+          </a:p>
+          <a:p>
+            <a:pPr>
+              <a:spcAft>
                 <a:spcPts val="400"/>
               </a:spcAft>
-              <a:defRPr sz="1350" b="1">
-                <a:solidFill>
-                  <a:srgbClr val="000000"/>
-                </a:solidFill>
-                <a:latin typeface="Segoe UI"/>
-              </a:defRPr>
-            </a:pPr>
-            <a:r>
-              <a:t>Checklist Langkah Praktikum di Lab:</a:t>
+              <a:defRPr sz="1040">
+                <a:solidFill>
+                  <a:srgbClr val="1E1E1E"/>
+                </a:solidFill>
+                <a:latin typeface="Segoe UI"/>
+              </a:defRPr>
+            </a:pPr>
+            <a:r>
+              <a:t>✔  Buka terminal VS Code dan jalankan 'flutter doctor' untuk memverifikasi kesiapan lingkungan kerja.</a:t>
             </a:r>
           </a:p>
           <a:p>
             <a:pPr>
               <a:spcAft>
-                <a:spcPts val="200"/>
+                <a:spcPts val="400"/>
               </a:spcAft>
-              <a:defRPr sz="1050">
+              <a:defRPr sz="1040">
                 <a:solidFill>
                   <a:srgbClr val="1E1E1E"/>
                 </a:solidFill>
@@ -9442,15 +9458,15 @@
               </a:defRPr>
             </a:pPr>
             <a:r>
-              <a:t>  [  ]   Buka terminal VS Code dan jalankan 'flutter doctor' untuk memverifikasi kesiapan lingkungan kerja.</a:t>
+              <a:t>✔  Buat proyek baru menggunakan perintah 'flutter create tugas_pertemuan_01'.</a:t>
             </a:r>
           </a:p>
           <a:p>
             <a:pPr>
               <a:spcAft>
-                <a:spcPts val="200"/>
+                <a:spcPts val="400"/>
               </a:spcAft>
-              <a:defRPr sz="1050">
+              <a:defRPr sz="1040">
                 <a:solidFill>
                   <a:srgbClr val="1E1E1E"/>
                 </a:solidFill>
@@ -9458,15 +9474,15 @@
               </a:defRPr>
             </a:pPr>
             <a:r>
-              <a:t>  [  ]   Buat proyek baru menggunakan perintah 'flutter create tugas_pertemuan_01'.</a:t>
+              <a:t>✔  Jalankan aplikasi ke target Google Chrome ('flutter run -d chrome') atau smartphone fisik via USB.</a:t>
             </a:r>
           </a:p>
           <a:p>
             <a:pPr>
               <a:spcAft>
-                <a:spcPts val="200"/>
+                <a:spcPts val="400"/>
               </a:spcAft>
-              <a:defRPr sz="1050">
+              <a:defRPr sz="1040">
                 <a:solidFill>
                   <a:srgbClr val="1E1E1E"/>
                 </a:solidFill>
@@ -9474,15 +9490,15 @@
               </a:defRPr>
             </a:pPr>
             <a:r>
-              <a:t>  [  ]   Jalankan aplikasi ke target Google Chrome ('flutter run -d chrome') atau smartphone fisik via USB.</a:t>
+              <a:t>✔  Buka berkas 'lib/main.dart', lalu ubah teks judul AppBar menjadi: 'Praktikum Mobile - [Nama Anda]'.</a:t>
             </a:r>
           </a:p>
           <a:p>
             <a:pPr>
               <a:spcAft>
-                <a:spcPts val="200"/>
+                <a:spcPts val="400"/>
               </a:spcAft>
-              <a:defRPr sz="1050">
+              <a:defRPr sz="1040">
                 <a:solidFill>
                   <a:srgbClr val="1E1E1E"/>
                 </a:solidFill>
@@ -9490,15 +9506,15 @@
               </a:defRPr>
             </a:pPr>
             <a:r>
-              <a:t>  [  ]   Buka berkas 'lib/main.dart', lalu ubah teks judul AppBar menjadi: 'Praktikum Mobile - [Nama Anda]'.</a:t>
+              <a:t>✔  Ubah teks di tengah layar menampilkan: 'Nama Lengkap Mahasiswa' dan 'NIM'.</a:t>
             </a:r>
           </a:p>
           <a:p>
             <a:pPr>
               <a:spcAft>
-                <a:spcPts val="200"/>
+                <a:spcPts val="400"/>
               </a:spcAft>
-              <a:defRPr sz="1050">
+              <a:defRPr sz="1040">
                 <a:solidFill>
                   <a:srgbClr val="1E1E1E"/>
                 </a:solidFill>
@@ -9506,15 +9522,15 @@
               </a:defRPr>
             </a:pPr>
             <a:r>
-              <a:t>  [  ]   Ubah teks di tengah layar menampilkan: 'Nama Lengkap Mahasiswa' dan 'NIM'.</a:t>
+              <a:t>✔  Ganti warna tema utama (seedColor) menjadi warna favorit Anda (misal: Colors.teal atau Colors.amber).</a:t>
             </a:r>
           </a:p>
           <a:p>
             <a:pPr>
               <a:spcAft>
-                <a:spcPts val="200"/>
+                <a:spcPts val="400"/>
               </a:spcAft>
-              <a:defRPr sz="1050">
+              <a:defRPr sz="1040">
                 <a:solidFill>
                   <a:srgbClr val="1E1E1E"/>
                 </a:solidFill>
@@ -9522,36 +9538,20 @@
               </a:defRPr>
             </a:pPr>
             <a:r>
-              <a:t>  [  ]   Ganti warna tema utama (seedColor) menjadi warna favorit Anda (misal: Colors.teal atau Colors.amber).</a:t>
-            </a:r>
-          </a:p>
-          <a:p>
-            <a:pPr>
-              <a:spcAft>
-                <a:spcPts val="200"/>
-              </a:spcAft>
-              <a:defRPr sz="1050">
-                <a:solidFill>
-                  <a:srgbClr val="1E1E1E"/>
-                </a:solidFill>
-                <a:latin typeface="Segoe UI"/>
-              </a:defRPr>
-            </a:pPr>
-            <a:r>
-              <a:t>  [  ]   Tekan 'Ctrl + S' (Hot Reload) dan buktikan layar aplikasi langsung berubah dalam sekejap tanpa restart!</a:t>
-            </a:r>
-          </a:p>
-          <a:p>
-            <a:pPr>
-              <a:defRPr sz="1100" b="1">
-                <a:solidFill>
-                  <a:srgbClr val="00823C"/>
-                </a:solidFill>
-                <a:latin typeface="Segoe UI"/>
-              </a:defRPr>
-            </a:pPr>
-            <a:r>
-              <a:t>✔ Kriteria Keberhasilan (Tunjukkan ke Dosen/Asisten Lab): Tunjukkan layar aplikasi yang menampilkan Nama, NIM, dan perubahan warna tema kepada Dosen atau Asisten Lab untuk mendapatkan checklist nilai modul 1.</a:t>
+              <a:t>✔  Tekan 'Ctrl + S' (Hot Reload) dan buktikan layar aplikasi langsung berubah dalam sekejap tanpa restart!</a:t>
+            </a:r>
+          </a:p>
+          <a:p>
+            <a:pPr>
+              <a:defRPr sz="1080" b="1">
+                <a:solidFill>
+                  <a:srgbClr val="0A6428"/>
+                </a:solidFill>
+                <a:latin typeface="Segoe UI"/>
+              </a:defRPr>
+            </a:pPr>
+            <a:r>
+              <a:t>🎯 TARGET SELESAI: Tunjukkan layar aplikasi yang menampilkan Nama, NIM, dan perubahan warna tema kepada Dosen atau Asisten Lab untuk mendapatkan checklist nilai modul 1.</a:t>
             </a:r>
           </a:p>
         </p:txBody>
@@ -9564,8 +9564,8 @@
         </p:nvSpPr>
         <p:spPr>
           <a:xfrm>
-            <a:off x="1225296" y="5669280"/>
-            <a:ext cx="9784080" cy="502920"/>
+            <a:off x="1225296" y="5632704"/>
+            <a:ext cx="9784080" cy="566928"/>
           </a:xfrm>
           <a:prstGeom prst="rect">
             <a:avLst/>
@@ -9607,14 +9607,14 @@
         </p:nvSpPr>
         <p:spPr>
           <a:xfrm>
-            <a:off x="1188720" y="5632704"/>
-            <a:ext cx="9784080" cy="502920"/>
-          </a:xfrm>
-          <a:prstGeom prst="rect">
-            <a:avLst/>
-          </a:prstGeom>
-          <a:solidFill>
-            <a:srgbClr val="4ADE80"/>
+            <a:off x="1188720" y="5596128"/>
+            <a:ext cx="9784080" cy="566928"/>
+          </a:xfrm>
+          <a:prstGeom prst="rect">
+            <a:avLst/>
+          </a:prstGeom>
+          <a:solidFill>
+            <a:srgbClr val="FFE600"/>
           </a:solidFill>
           <a:ln w="25400">
             <a:solidFill>
@@ -9652,8 +9652,8 @@
         </p:nvSpPr>
         <p:spPr>
           <a:xfrm>
-            <a:off x="1261872" y="5660136"/>
-            <a:ext cx="9637776" cy="448056"/>
+            <a:off x="1298448" y="5623560"/>
+            <a:ext cx="9564624" cy="512064"/>
           </a:xfrm>
           <a:prstGeom prst="rect">
             <a:avLst/>
@@ -9667,7 +9667,7 @@
           <a:lstStyle/>
           <a:p>
             <a:r>
-              <a:rPr sz="1000" b="1">
+              <a:rPr sz="1100" b="1">
                 <a:solidFill>
                   <a:srgbClr val="000000"/>
                 </a:solidFill>
@@ -9675,6 +9675,19 @@
                 <a:hlinkClick r:id="rId2"/>
               </a:rPr>
               <a:t>▶ BUKA KODE SOLUSI LENGKAP LAB QUEST DI GITHUB (slide_17_lab_quest_tugas_01.dart)</a:t>
+            </a:r>
+          </a:p>
+          <a:p>
+            <a:pPr>
+              <a:defRPr sz="830">
+                <a:solidFill>
+                  <a:srgbClr val="323232"/>
+                </a:solidFill>
+                <a:latin typeface="Segoe UI"/>
+              </a:defRPr>
+            </a:pPr>
+            <a:r>
+              <a:t>💡 Buka di browser / salin source code: github.com/antonprafanto/mobile2026</a:t>
             </a:r>
           </a:p>
         </p:txBody>
@@ -10022,15 +10035,15 @@
               </a:defRPr>
             </a:pPr>
             <a:r>
-              <a:t>KONSEP &amp; CARA KERJA</a:t>
+              <a:t>KONSEP &amp; ALUR KERJA</a:t>
             </a:r>
           </a:p>
           <a:p>
             <a:pPr>
               <a:spcAft>
-                <a:spcPts val="600"/>
+                <a:spcPts val="500"/>
               </a:spcAft>
-              <a:defRPr sz="1100">
+              <a:defRPr sz="1060">
                 <a:solidFill>
                   <a:srgbClr val="141414"/>
                 </a:solidFill>
@@ -10044,9 +10057,9 @@
           <a:p>
             <a:pPr>
               <a:spcAft>
-                <a:spcPts val="600"/>
+                <a:spcPts val="500"/>
               </a:spcAft>
-              <a:defRPr sz="1100">
+              <a:defRPr sz="1060">
                 <a:solidFill>
                   <a:srgbClr val="141414"/>
                 </a:solidFill>
@@ -10060,9 +10073,9 @@
           <a:p>
             <a:pPr>
               <a:spcAft>
-                <a:spcPts val="600"/>
+                <a:spcPts val="500"/>
               </a:spcAft>
-              <a:defRPr sz="1100">
+              <a:defRPr sz="1060">
                 <a:solidFill>
                   <a:srgbClr val="141414"/>
                 </a:solidFill>
@@ -10075,7 +10088,7 @@
           </a:p>
           <a:p>
             <a:pPr>
-              <a:defRPr sz="1050" b="1">
+              <a:defRPr sz="1019" b="1">
                 <a:solidFill>
                   <a:srgbClr val="000000"/>
                 </a:solidFill>
@@ -10083,7 +10096,7 @@
               </a:defRPr>
             </a:pPr>
             <a:r>
-              <a:t>💡 Tips Praktik: Buka dartpad.dev di rumah untuk mulai mencicipi sintaks Dart tanpa perlu instalasi tambahan!</a:t>
+              <a:t>💡 Tips Praktis: Buka dartpad.dev di rumah untuk mulai mencicipi sintaks Dart tanpa perlu instalasi tambahan!</a:t>
             </a:r>
           </a:p>
         </p:txBody>
@@ -10280,7 +10293,7 @@
           <a:lstStyle/>
           <a:p>
             <a:pPr>
-              <a:defRPr sz="919">
+              <a:defRPr sz="910">
                 <a:solidFill>
                   <a:srgbClr val="F5F5F5"/>
                 </a:solidFill>
@@ -10810,15 +10823,15 @@
               </a:defRPr>
             </a:pPr>
             <a:r>
-              <a:t>KONSEP &amp; CARA KERJA</a:t>
+              <a:t>KONSEP &amp; ALUR KERJA</a:t>
             </a:r>
           </a:p>
           <a:p>
             <a:pPr>
               <a:spcAft>
-                <a:spcPts val="600"/>
+                <a:spcPts val="500"/>
               </a:spcAft>
-              <a:defRPr sz="1100">
+              <a:defRPr sz="1060">
                 <a:solidFill>
                   <a:srgbClr val="141414"/>
                 </a:solidFill>
@@ -10832,9 +10845,9 @@
           <a:p>
             <a:pPr>
               <a:spcAft>
-                <a:spcPts val="600"/>
+                <a:spcPts val="500"/>
               </a:spcAft>
-              <a:defRPr sz="1100">
+              <a:defRPr sz="1060">
                 <a:solidFill>
                   <a:srgbClr val="141414"/>
                 </a:solidFill>
@@ -10848,9 +10861,9 @@
           <a:p>
             <a:pPr>
               <a:spcAft>
-                <a:spcPts val="600"/>
+                <a:spcPts val="500"/>
               </a:spcAft>
-              <a:defRPr sz="1100">
+              <a:defRPr sz="1060">
                 <a:solidFill>
                   <a:srgbClr val="141414"/>
                 </a:solidFill>
@@ -10864,9 +10877,9 @@
           <a:p>
             <a:pPr>
               <a:spcAft>
-                <a:spcPts val="600"/>
+                <a:spcPts val="500"/>
               </a:spcAft>
-              <a:defRPr sz="1100">
+              <a:defRPr sz="1060">
                 <a:solidFill>
                   <a:srgbClr val="141414"/>
                 </a:solidFill>
@@ -10879,7 +10892,7 @@
           </a:p>
           <a:p>
             <a:pPr>
-              <a:defRPr sz="1050" b="1">
+              <a:defRPr sz="1019" b="1">
                 <a:solidFill>
                   <a:srgbClr val="000000"/>
                 </a:solidFill>
@@ -10887,7 +10900,7 @@
               </a:defRPr>
             </a:pPr>
             <a:r>
-              <a:t>💡 Tips Praktik: Fokuslah pada pemahaman pola arsitektur, bukan sekadar menghafal sintaks!</a:t>
+              <a:t>💡 Tips Praktis: Fokuslah pada pemahaman pola arsitektur, bukan sekadar menghafal sintaks!</a:t>
             </a:r>
           </a:p>
         </p:txBody>
@@ -10995,7 +11008,7 @@
             <a:avLst/>
           </a:prstGeom>
           <a:solidFill>
-            <a:srgbClr val="FFE600"/>
+            <a:srgbClr val="4ADE80"/>
           </a:solidFill>
           <a:ln w="31750">
             <a:solidFill>
@@ -11084,7 +11097,7 @@
           <a:lstStyle/>
           <a:p>
             <a:pPr>
-              <a:defRPr sz="919">
+              <a:defRPr sz="910">
                 <a:solidFill>
                   <a:srgbClr val="F5F5F5"/>
                 </a:solidFill>
@@ -11613,15 +11626,15 @@
               </a:defRPr>
             </a:pPr>
             <a:r>
-              <a:t>KONSEP &amp; CARA KERJA</a:t>
+              <a:t>KONSEP &amp; ALUR KERJA</a:t>
             </a:r>
           </a:p>
           <a:p>
             <a:pPr>
               <a:spcAft>
-                <a:spcPts val="600"/>
+                <a:spcPts val="500"/>
               </a:spcAft>
-              <a:defRPr sz="1100">
+              <a:defRPr sz="1060">
                 <a:solidFill>
                   <a:srgbClr val="141414"/>
                 </a:solidFill>
@@ -11635,9 +11648,9 @@
           <a:p>
             <a:pPr>
               <a:spcAft>
-                <a:spcPts val="600"/>
+                <a:spcPts val="500"/>
               </a:spcAft>
-              <a:defRPr sz="1100">
+              <a:defRPr sz="1060">
                 <a:solidFill>
                   <a:srgbClr val="141414"/>
                 </a:solidFill>
@@ -11651,9 +11664,9 @@
           <a:p>
             <a:pPr>
               <a:spcAft>
-                <a:spcPts val="600"/>
+                <a:spcPts val="500"/>
               </a:spcAft>
-              <a:defRPr sz="1100">
+              <a:defRPr sz="1060">
                 <a:solidFill>
                   <a:srgbClr val="141414"/>
                 </a:solidFill>
@@ -11667,9 +11680,9 @@
           <a:p>
             <a:pPr>
               <a:spcAft>
-                <a:spcPts val="600"/>
+                <a:spcPts val="500"/>
               </a:spcAft>
-              <a:defRPr sz="1100">
+              <a:defRPr sz="1060">
                 <a:solidFill>
                   <a:srgbClr val="141414"/>
                 </a:solidFill>
@@ -11682,7 +11695,7 @@
           </a:p>
           <a:p>
             <a:pPr>
-              <a:defRPr sz="1050" b="1">
+              <a:defRPr sz="1019" b="1">
                 <a:solidFill>
                   <a:srgbClr val="000000"/>
                 </a:solidFill>
@@ -11690,7 +11703,7 @@
               </a:defRPr>
             </a:pPr>
             <a:r>
-              <a:t>💡 Tips Praktik: Perusahaan startup lebih memilih Flutter karena 'Time-to-Market' yang sangat cepat!</a:t>
+              <a:t>💡 Tips Praktis: Perusahaan startup lebih memilih Flutter karena 'Time-to-Market' yang sangat cepat!</a:t>
             </a:r>
           </a:p>
         </p:txBody>
@@ -11887,7 +11900,7 @@
           <a:lstStyle/>
           <a:p>
             <a:pPr>
-              <a:defRPr sz="919">
+              <a:defRPr sz="910">
                 <a:solidFill>
                   <a:srgbClr val="F5F5F5"/>
                 </a:solidFill>
@@ -12408,15 +12421,15 @@
               </a:defRPr>
             </a:pPr>
             <a:r>
-              <a:t>KONSEP &amp; CARA KERJA</a:t>
+              <a:t>KONSEP &amp; ALUR KERJA</a:t>
             </a:r>
           </a:p>
           <a:p>
             <a:pPr>
               <a:spcAft>
-                <a:spcPts val="600"/>
+                <a:spcPts val="500"/>
               </a:spcAft>
-              <a:defRPr sz="1100">
+              <a:defRPr sz="1060">
                 <a:solidFill>
                   <a:srgbClr val="141414"/>
                 </a:solidFill>
@@ -12430,9 +12443,9 @@
           <a:p>
             <a:pPr>
               <a:spcAft>
-                <a:spcPts val="600"/>
+                <a:spcPts val="500"/>
               </a:spcAft>
-              <a:defRPr sz="1100">
+              <a:defRPr sz="1060">
                 <a:solidFill>
                   <a:srgbClr val="141414"/>
                 </a:solidFill>
@@ -12446,9 +12459,9 @@
           <a:p>
             <a:pPr>
               <a:spcAft>
-                <a:spcPts val="600"/>
+                <a:spcPts val="500"/>
               </a:spcAft>
-              <a:defRPr sz="1100">
+              <a:defRPr sz="1060">
                 <a:solidFill>
                   <a:srgbClr val="141414"/>
                 </a:solidFill>
@@ -12462,9 +12475,9 @@
           <a:p>
             <a:pPr>
               <a:spcAft>
-                <a:spcPts val="600"/>
+                <a:spcPts val="500"/>
               </a:spcAft>
-              <a:defRPr sz="1100">
+              <a:defRPr sz="1060">
                 <a:solidFill>
                   <a:srgbClr val="141414"/>
                 </a:solidFill>
@@ -12477,7 +12490,7 @@
           </a:p>
           <a:p>
             <a:pPr>
-              <a:defRPr sz="1050" b="1">
+              <a:defRPr sz="1019" b="1">
                 <a:solidFill>
                   <a:srgbClr val="000000"/>
                 </a:solidFill>
@@ -12485,7 +12498,7 @@
               </a:defRPr>
             </a:pPr>
             <a:r>
-              <a:t>💡 Tips Praktik: Anda mengetik kode menggunakan bahasa Dart, untuk memanggil widget buatan Flutter!</a:t>
+              <a:t>💡 Tips Praktis: Anda mengetik kode menggunakan bahasa Dart, untuk memanggil widget buatan Flutter!</a:t>
             </a:r>
           </a:p>
         </p:txBody>
@@ -12593,7 +12606,7 @@
             <a:avLst/>
           </a:prstGeom>
           <a:solidFill>
-            <a:srgbClr val="FFE600"/>
+            <a:srgbClr val="38BDF8"/>
           </a:solidFill>
           <a:ln w="31750">
             <a:solidFill>
@@ -12682,7 +12695,7 @@
           <a:lstStyle/>
           <a:p>
             <a:pPr>
-              <a:defRPr sz="919">
+              <a:defRPr sz="910">
                 <a:solidFill>
                   <a:srgbClr val="F5F5F5"/>
                 </a:solidFill>
@@ -13215,15 +13228,15 @@
               </a:defRPr>
             </a:pPr>
             <a:r>
-              <a:t>KONSEP &amp; CARA KERJA</a:t>
+              <a:t>KONSEP &amp; ALUR KERJA</a:t>
             </a:r>
           </a:p>
           <a:p>
             <a:pPr>
               <a:spcAft>
-                <a:spcPts val="600"/>
+                <a:spcPts val="500"/>
               </a:spcAft>
-              <a:defRPr sz="1100">
+              <a:defRPr sz="1060">
                 <a:solidFill>
                   <a:srgbClr val="141414"/>
                 </a:solidFill>
@@ -13237,9 +13250,9 @@
           <a:p>
             <a:pPr>
               <a:spcAft>
-                <a:spcPts val="600"/>
+                <a:spcPts val="500"/>
               </a:spcAft>
-              <a:defRPr sz="1100">
+              <a:defRPr sz="1060">
                 <a:solidFill>
                   <a:srgbClr val="141414"/>
                 </a:solidFill>
@@ -13253,9 +13266,9 @@
           <a:p>
             <a:pPr>
               <a:spcAft>
-                <a:spcPts val="600"/>
+                <a:spcPts val="500"/>
               </a:spcAft>
-              <a:defRPr sz="1100">
+              <a:defRPr sz="1060">
                 <a:solidFill>
                   <a:srgbClr val="141414"/>
                 </a:solidFill>
@@ -13269,9 +13282,9 @@
           <a:p>
             <a:pPr>
               <a:spcAft>
-                <a:spcPts val="600"/>
+                <a:spcPts val="500"/>
               </a:spcAft>
-              <a:defRPr sz="1100">
+              <a:defRPr sz="1060">
                 <a:solidFill>
                   <a:srgbClr val="141414"/>
                 </a:solidFill>
@@ -13284,7 +13297,7 @@
           </a:p>
           <a:p>
             <a:pPr>
-              <a:defRPr sz="1050" b="1">
+              <a:defRPr sz="1019" b="1">
                 <a:solidFill>
                   <a:srgbClr val="000000"/>
                 </a:solidFill>
@@ -13292,7 +13305,7 @@
               </a:defRPr>
             </a:pPr>
             <a:r>
-              <a:t>💡 Tips Praktik: Karena menggambar sendiri pikselnya, Flutter bebas dari bug perbedaan OS Android antar vendor!</a:t>
+              <a:t>💡 Tips Praktis: Karena menggambar sendiri pikselnya, Flutter bebas dari bug perbedaan OS Android antar vendor!</a:t>
             </a:r>
           </a:p>
         </p:txBody>
@@ -13400,7 +13413,7 @@
             <a:avLst/>
           </a:prstGeom>
           <a:solidFill>
-            <a:srgbClr val="FFE600"/>
+            <a:srgbClr val="C084FC"/>
           </a:solidFill>
           <a:ln w="31750">
             <a:solidFill>
@@ -13489,7 +13502,7 @@
           <a:lstStyle/>
           <a:p>
             <a:pPr>
-              <a:defRPr sz="919">
+              <a:defRPr sz="910">
                 <a:solidFill>
                   <a:srgbClr val="F5F5F5"/>
                 </a:solidFill>
@@ -14006,15 +14019,15 @@
               </a:defRPr>
             </a:pPr>
             <a:r>
-              <a:t>KONSEP &amp; CARA KERJA</a:t>
+              <a:t>KONSEP &amp; ALUR KERJA</a:t>
             </a:r>
           </a:p>
           <a:p>
             <a:pPr>
               <a:spcAft>
-                <a:spcPts val="600"/>
+                <a:spcPts val="500"/>
               </a:spcAft>
-              <a:defRPr sz="1100">
+              <a:defRPr sz="1060">
                 <a:solidFill>
                   <a:srgbClr val="141414"/>
                 </a:solidFill>
@@ -14028,9 +14041,9 @@
           <a:p>
             <a:pPr>
               <a:spcAft>
-                <a:spcPts val="600"/>
+                <a:spcPts val="500"/>
               </a:spcAft>
-              <a:defRPr sz="1100">
+              <a:defRPr sz="1060">
                 <a:solidFill>
                   <a:srgbClr val="141414"/>
                 </a:solidFill>
@@ -14044,9 +14057,9 @@
           <a:p>
             <a:pPr>
               <a:spcAft>
-                <a:spcPts val="600"/>
+                <a:spcPts val="500"/>
               </a:spcAft>
-              <a:defRPr sz="1100">
+              <a:defRPr sz="1060">
                 <a:solidFill>
                   <a:srgbClr val="141414"/>
                 </a:solidFill>
@@ -14060,9 +14073,9 @@
           <a:p>
             <a:pPr>
               <a:spcAft>
-                <a:spcPts val="600"/>
+                <a:spcPts val="500"/>
               </a:spcAft>
-              <a:defRPr sz="1100">
+              <a:defRPr sz="1060">
                 <a:solidFill>
                   <a:srgbClr val="141414"/>
                 </a:solidFill>
@@ -14075,7 +14088,7 @@
           </a:p>
           <a:p>
             <a:pPr>
-              <a:defRPr sz="1050" b="1">
+              <a:defRPr sz="1019" b="1">
                 <a:solidFill>
                   <a:srgbClr val="000000"/>
                 </a:solidFill>
@@ -14083,7 +14096,7 @@
               </a:defRPr>
             </a:pPr>
             <a:r>
-              <a:t>💡 Tips Praktik: Impeller adalah alasan mengapa aplikasi perbankan modern beralih ke Flutter!</a:t>
+              <a:t>💡 Tips Praktis: Impeller adalah alasan mengapa aplikasi perbankan modern beralih ke Flutter!</a:t>
             </a:r>
           </a:p>
         </p:txBody>
@@ -14191,7 +14204,7 @@
             <a:avLst/>
           </a:prstGeom>
           <a:solidFill>
-            <a:srgbClr val="FFE600"/>
+            <a:srgbClr val="FB7185"/>
           </a:solidFill>
           <a:ln w="31750">
             <a:solidFill>
@@ -14280,7 +14293,7 @@
           <a:lstStyle/>
           <a:p>
             <a:pPr>
-              <a:defRPr sz="919">
+              <a:defRPr sz="910">
                 <a:solidFill>
                   <a:srgbClr val="F5F5F5"/>
                 </a:solidFill>
@@ -14798,15 +14811,15 @@
               </a:defRPr>
             </a:pPr>
             <a:r>
-              <a:t>KONSEP &amp; CARA KERJA</a:t>
+              <a:t>KONSEP &amp; ALUR KERJA</a:t>
             </a:r>
           </a:p>
           <a:p>
             <a:pPr>
               <a:spcAft>
-                <a:spcPts val="600"/>
+                <a:spcPts val="500"/>
               </a:spcAft>
-              <a:defRPr sz="1100">
+              <a:defRPr sz="1060">
                 <a:solidFill>
                   <a:srgbClr val="141414"/>
                 </a:solidFill>
@@ -14820,9 +14833,9 @@
           <a:p>
             <a:pPr>
               <a:spcAft>
-                <a:spcPts val="600"/>
+                <a:spcPts val="500"/>
               </a:spcAft>
-              <a:defRPr sz="1100">
+              <a:defRPr sz="1060">
                 <a:solidFill>
                   <a:srgbClr val="141414"/>
                 </a:solidFill>
@@ -14836,9 +14849,9 @@
           <a:p>
             <a:pPr>
               <a:spcAft>
-                <a:spcPts val="600"/>
+                <a:spcPts val="500"/>
               </a:spcAft>
-              <a:defRPr sz="1100">
+              <a:defRPr sz="1060">
                 <a:solidFill>
                   <a:srgbClr val="141414"/>
                 </a:solidFill>
@@ -14852,9 +14865,9 @@
           <a:p>
             <a:pPr>
               <a:spcAft>
-                <a:spcPts val="600"/>
+                <a:spcPts val="500"/>
               </a:spcAft>
-              <a:defRPr sz="1100">
+              <a:defRPr sz="1060">
                 <a:solidFill>
                   <a:srgbClr val="141414"/>
                 </a:solidFill>
@@ -14867,7 +14880,7 @@
           </a:p>
           <a:p>
             <a:pPr>
-              <a:defRPr sz="1050" b="1">
+              <a:defRPr sz="1019" b="1">
                 <a:solidFill>
                   <a:srgbClr val="000000"/>
                 </a:solidFill>
@@ -14875,7 +14888,7 @@
               </a:defRPr>
             </a:pPr>
             <a:r>
-              <a:t>💡 Tips Praktik: Jangan panik jika Android Studio silang merah, asalkan Chrome dan VS Code bertanda centang hijau!</a:t>
+              <a:t>💡 Tips Praktis: Jangan panik jika Android Studio silang merah, asalkan Chrome dan VS Code bertanda centang hijau!</a:t>
             </a:r>
           </a:p>
         </p:txBody>
@@ -14983,7 +14996,7 @@
             <a:avLst/>
           </a:prstGeom>
           <a:solidFill>
-            <a:srgbClr val="FFE600"/>
+            <a:srgbClr val="4ADE80"/>
           </a:solidFill>
           <a:ln w="31750">
             <a:solidFill>
@@ -15072,7 +15085,7 @@
           <a:lstStyle/>
           <a:p>
             <a:pPr>
-              <a:defRPr sz="919">
+              <a:defRPr sz="910">
                 <a:solidFill>
                   <a:srgbClr val="F5F5F5"/>
                 </a:solidFill>
@@ -15598,15 +15611,15 @@
               </a:defRPr>
             </a:pPr>
             <a:r>
-              <a:t>KONSEP &amp; CARA KERJA</a:t>
+              <a:t>KONSEP &amp; ALUR KERJA</a:t>
             </a:r>
           </a:p>
           <a:p>
             <a:pPr>
               <a:spcAft>
-                <a:spcPts val="600"/>
+                <a:spcPts val="500"/>
               </a:spcAft>
-              <a:defRPr sz="1100">
+              <a:defRPr sz="1060">
                 <a:solidFill>
                   <a:srgbClr val="141414"/>
                 </a:solidFill>
@@ -15620,9 +15633,9 @@
           <a:p>
             <a:pPr>
               <a:spcAft>
-                <a:spcPts val="600"/>
+                <a:spcPts val="500"/>
               </a:spcAft>
-              <a:defRPr sz="1100">
+              <a:defRPr sz="1060">
                 <a:solidFill>
                   <a:srgbClr val="141414"/>
                 </a:solidFill>
@@ -15636,9 +15649,9 @@
           <a:p>
             <a:pPr>
               <a:spcAft>
-                <a:spcPts val="600"/>
+                <a:spcPts val="500"/>
               </a:spcAft>
-              <a:defRPr sz="1100">
+              <a:defRPr sz="1060">
                 <a:solidFill>
                   <a:srgbClr val="141414"/>
                 </a:solidFill>
@@ -15652,9 +15665,9 @@
           <a:p>
             <a:pPr>
               <a:spcAft>
-                <a:spcPts val="600"/>
+                <a:spcPts val="500"/>
               </a:spcAft>
-              <a:defRPr sz="1100">
+              <a:defRPr sz="1060">
                 <a:solidFill>
                   <a:srgbClr val="141414"/>
                 </a:solidFill>
@@ -15667,7 +15680,7 @@
           </a:p>
           <a:p>
             <a:pPr>
-              <a:defRPr sz="1050" b="1">
+              <a:defRPr sz="1019" b="1">
                 <a:solidFill>
                   <a:srgbClr val="000000"/>
                 </a:solidFill>
@@ -15675,7 +15688,7 @@
               </a:defRPr>
             </a:pPr>
             <a:r>
-              <a:t>💡 Tips Praktik: Selalu gunakan huruf kecil dan underscore agar tidak memicu galat kompilator Dart!</a:t>
+              <a:t>💡 Tips Praktis: Selalu gunakan huruf kecil dan underscore agar tidak memicu galat kompilator Dart!</a:t>
             </a:r>
           </a:p>
         </p:txBody>
@@ -15872,7 +15885,7 @@
           <a:lstStyle/>
           <a:p>
             <a:pPr>
-              <a:defRPr sz="919">
+              <a:defRPr sz="910">
                 <a:solidFill>
                   <a:srgbClr val="F5F5F5"/>
                 </a:solidFill>
@@ -16395,15 +16408,15 @@
               </a:defRPr>
             </a:pPr>
             <a:r>
-              <a:t>KONSEP &amp; CARA KERJA</a:t>
+              <a:t>KONSEP &amp; ALUR KERJA</a:t>
             </a:r>
           </a:p>
           <a:p>
             <a:pPr>
               <a:spcAft>
-                <a:spcPts val="600"/>
+                <a:spcPts val="500"/>
               </a:spcAft>
-              <a:defRPr sz="1100">
+              <a:defRPr sz="1060">
                 <a:solidFill>
                   <a:srgbClr val="141414"/>
                 </a:solidFill>
@@ -16417,9 +16430,9 @@
           <a:p>
             <a:pPr>
               <a:spcAft>
-                <a:spcPts val="600"/>
+                <a:spcPts val="500"/>
               </a:spcAft>
-              <a:defRPr sz="1100">
+              <a:defRPr sz="1060">
                 <a:solidFill>
                   <a:srgbClr val="141414"/>
                 </a:solidFill>
@@ -16433,9 +16446,9 @@
           <a:p>
             <a:pPr>
               <a:spcAft>
-                <a:spcPts val="600"/>
+                <a:spcPts val="500"/>
               </a:spcAft>
-              <a:defRPr sz="1100">
+              <a:defRPr sz="1060">
                 <a:solidFill>
                   <a:srgbClr val="141414"/>
                 </a:solidFill>
@@ -16449,9 +16462,9 @@
           <a:p>
             <a:pPr>
               <a:spcAft>
-                <a:spcPts val="600"/>
+                <a:spcPts val="500"/>
               </a:spcAft>
-              <a:defRPr sz="1100">
+              <a:defRPr sz="1060">
                 <a:solidFill>
                   <a:srgbClr val="141414"/>
                 </a:solidFill>
@@ -16464,7 +16477,7 @@
           </a:p>
           <a:p>
             <a:pPr>
-              <a:defRPr sz="1050" b="1">
+              <a:defRPr sz="1019" b="1">
                 <a:solidFill>
                   <a:srgbClr val="000000"/>
                 </a:solidFill>
@@ -16472,7 +16485,7 @@
               </a:defRPr>
             </a:pPr>
             <a:r>
-              <a:t>💡 Tips Praktik: Fokuskan perhatian Anda 100% hanya pada folder 'lib/' dan berkas 'pubspec.yaml'!</a:t>
+              <a:t>💡 Tips Praktis: Fokuskan perhatian Anda 100% hanya pada folder 'lib/' dan berkas 'pubspec.yaml'!</a:t>
             </a:r>
           </a:p>
         </p:txBody>
@@ -16580,7 +16593,7 @@
             <a:avLst/>
           </a:prstGeom>
           <a:solidFill>
-            <a:srgbClr val="FFE600"/>
+            <a:srgbClr val="38BDF8"/>
           </a:solidFill>
           <a:ln w="31750">
             <a:solidFill>
@@ -16669,7 +16682,7 @@
           <a:lstStyle/>
           <a:p>
             <a:pPr>
-              <a:defRPr sz="919">
+              <a:defRPr sz="910">
                 <a:solidFill>
                   <a:srgbClr val="F5F5F5"/>
                 </a:solidFill>

</xml_diff>